<commit_message>
Publish five certified Alder Ridge sample tasks
</commit_message>
<xml_diff>
--- a/environment/seed/sources/Shared/Finance/Reporting/2026/06 June/June executive performance review - WORKING.pptx
+++ b/environment/seed/sources/Shared/Finance/Reporting/2026/06 June/June executive performance review - WORKING.pptx
@@ -2,119 +2,24 @@
 <file path=ppt/presentation.xml><?xml version="1.0" encoding="utf-8"?>
 <p:presentation xmlns:p="http://schemas.openxmlformats.org/presentationml/2006/main">
   <p:sldMasterIdLst>
-    <p:sldMasterId xmlns:r="http://schemas.openxmlformats.org/officeDocument/2006/relationships" id="2147483648" r:id="Rd5629cf2255e4328"/>
+    <p:sldMasterId xmlns:r="http://schemas.openxmlformats.org/officeDocument/2006/relationships" id="2147483648" r:id="R71e81ee91b52429f"/>
   </p:sldMasterIdLst>
   <p:notesMasterIdLst>
-    <p:notesMasterId xmlns:r="http://schemas.openxmlformats.org/officeDocument/2006/relationships" r:id="Rf5f8056b49714270"/>
+    <p:notesMasterId xmlns:r="http://schemas.openxmlformats.org/officeDocument/2006/relationships" r:id="R850ef550a6114dc3"/>
   </p:notesMasterIdLst>
   <p:sldIdLst>
-    <p:sldId xmlns:r="http://schemas.openxmlformats.org/officeDocument/2006/relationships" id="256" r:id="R8c8341f0ba29405d"/>
-    <p:sldId xmlns:r="http://schemas.openxmlformats.org/officeDocument/2006/relationships" id="257" r:id="Raf54522900c44072"/>
-    <p:sldId xmlns:r="http://schemas.openxmlformats.org/officeDocument/2006/relationships" id="258" r:id="Re4eb2750bfe548e5"/>
-    <p:sldId xmlns:r="http://schemas.openxmlformats.org/officeDocument/2006/relationships" id="259" r:id="R270932117cb54841"/>
-    <p:sldId xmlns:r="http://schemas.openxmlformats.org/officeDocument/2006/relationships" id="260" r:id="Rebf2da9b027a47d4"/>
-    <p:sldId xmlns:r="http://schemas.openxmlformats.org/officeDocument/2006/relationships" id="261" r:id="Re27b0b973447464a"/>
-    <p:sldId xmlns:r="http://schemas.openxmlformats.org/officeDocument/2006/relationships" id="262" r:id="Rfcd72977f3254bd9"/>
-    <p:sldId xmlns:r="http://schemas.openxmlformats.org/officeDocument/2006/relationships" id="263" r:id="R13e4c75cab9f4add"/>
-    <p:sldId xmlns:r="http://schemas.openxmlformats.org/officeDocument/2006/relationships" id="264" r:id="R6ccfea770cef4afd"/>
+    <p:sldId xmlns:r="http://schemas.openxmlformats.org/officeDocument/2006/relationships" id="256" r:id="R28268eb886174e98"/>
+    <p:sldId xmlns:r="http://schemas.openxmlformats.org/officeDocument/2006/relationships" id="257" r:id="R87000400873246ca"/>
+    <p:sldId xmlns:r="http://schemas.openxmlformats.org/officeDocument/2006/relationships" id="258" r:id="R8063e149717144bf"/>
+    <p:sldId xmlns:r="http://schemas.openxmlformats.org/officeDocument/2006/relationships" id="259" r:id="R915c14d3d17144f4"/>
+    <p:sldId xmlns:r="http://schemas.openxmlformats.org/officeDocument/2006/relationships" id="260" r:id="R3d3814580c9f4ba3"/>
+    <p:sldId xmlns:r="http://schemas.openxmlformats.org/officeDocument/2006/relationships" id="261" r:id="R753dc3ec5a9e4056"/>
+    <p:sldId xmlns:r="http://schemas.openxmlformats.org/officeDocument/2006/relationships" id="262" r:id="R8309d039f1bf4c0c"/>
+    <p:sldId xmlns:r="http://schemas.openxmlformats.org/officeDocument/2006/relationships" id="263" r:id="Rc7c2d597a22e418c"/>
+    <p:sldId xmlns:r="http://schemas.openxmlformats.org/officeDocument/2006/relationships" id="264" r:id="R6f2f37fd426846af"/>
   </p:sldIdLst>
   <p:sldSz cx="12192000" cy="6858000"/>
   <p:notesSz cx="6858000" cy="9144000"/>
-  <p:defaultTextStyle>
-    <a:defPPr xmlns:a="http://schemas.openxmlformats.org/drawingml/2006/main">
-      <a:defRPr lang="en-US"/>
-    </a:defPPr>
-    <a:lvl1pPr xmlns:a="http://schemas.openxmlformats.org/drawingml/2006/main" marL="0" indent="0" algn="l" defTabSz="914400">
-      <a:defRPr sz="1800" kern="1200">
-        <a:solidFill>
-          <a:schemeClr val="tx1"/>
-        </a:solidFill>
-        <a:latin typeface="+mn-lt"/>
-        <a:ea typeface="+mn-ea"/>
-        <a:cs typeface="+mn-cs"/>
-      </a:defRPr>
-    </a:lvl1pPr>
-    <a:lvl2pPr xmlns:a="http://schemas.openxmlformats.org/drawingml/2006/main" marL="457200" indent="0" algn="l" defTabSz="914400">
-      <a:defRPr sz="1800" kern="1200">
-        <a:solidFill>
-          <a:schemeClr val="tx1"/>
-        </a:solidFill>
-        <a:latin typeface="+mn-lt"/>
-        <a:ea typeface="+mn-ea"/>
-        <a:cs typeface="+mn-cs"/>
-      </a:defRPr>
-    </a:lvl2pPr>
-    <a:lvl3pPr xmlns:a="http://schemas.openxmlformats.org/drawingml/2006/main" marL="914400" indent="0" algn="l" defTabSz="914400">
-      <a:defRPr sz="1800" kern="1200">
-        <a:solidFill>
-          <a:schemeClr val="tx1"/>
-        </a:solidFill>
-        <a:latin typeface="+mn-lt"/>
-        <a:ea typeface="+mn-ea"/>
-        <a:cs typeface="+mn-cs"/>
-      </a:defRPr>
-    </a:lvl3pPr>
-    <a:lvl4pPr xmlns:a="http://schemas.openxmlformats.org/drawingml/2006/main" marL="1371600" indent="0" algn="l" defTabSz="914400">
-      <a:defRPr sz="1800" kern="1200">
-        <a:solidFill>
-          <a:schemeClr val="tx1"/>
-        </a:solidFill>
-        <a:latin typeface="+mn-lt"/>
-        <a:ea typeface="+mn-ea"/>
-        <a:cs typeface="+mn-cs"/>
-      </a:defRPr>
-    </a:lvl4pPr>
-    <a:lvl5pPr xmlns:a="http://schemas.openxmlformats.org/drawingml/2006/main" marL="1828800" indent="0" algn="l" defTabSz="914400">
-      <a:defRPr sz="1800" kern="1200">
-        <a:solidFill>
-          <a:schemeClr val="tx1"/>
-        </a:solidFill>
-        <a:latin typeface="+mn-lt"/>
-        <a:ea typeface="+mn-ea"/>
-        <a:cs typeface="+mn-cs"/>
-      </a:defRPr>
-    </a:lvl5pPr>
-    <a:lvl6pPr xmlns:a="http://schemas.openxmlformats.org/drawingml/2006/main" marL="2286000" indent="0" algn="l" defTabSz="914400">
-      <a:defRPr sz="1800" kern="1200">
-        <a:solidFill>
-          <a:schemeClr val="tx1"/>
-        </a:solidFill>
-        <a:latin typeface="+mn-lt"/>
-        <a:ea typeface="+mn-ea"/>
-        <a:cs typeface="+mn-cs"/>
-      </a:defRPr>
-    </a:lvl6pPr>
-    <a:lvl7pPr xmlns:a="http://schemas.openxmlformats.org/drawingml/2006/main" marL="2743200" indent="0" algn="l" defTabSz="914400">
-      <a:defRPr sz="1800" kern="1200">
-        <a:solidFill>
-          <a:schemeClr val="tx1"/>
-        </a:solidFill>
-        <a:latin typeface="+mn-lt"/>
-        <a:ea typeface="+mn-ea"/>
-        <a:cs typeface="+mn-cs"/>
-      </a:defRPr>
-    </a:lvl7pPr>
-    <a:lvl8pPr xmlns:a="http://schemas.openxmlformats.org/drawingml/2006/main" marL="3200400" indent="0" algn="l" defTabSz="914400">
-      <a:defRPr sz="1800" kern="1200">
-        <a:solidFill>
-          <a:schemeClr val="tx1"/>
-        </a:solidFill>
-        <a:latin typeface="+mn-lt"/>
-        <a:ea typeface="+mn-ea"/>
-        <a:cs typeface="+mn-cs"/>
-      </a:defRPr>
-    </a:lvl8pPr>
-    <a:lvl9pPr xmlns:a="http://schemas.openxmlformats.org/drawingml/2006/main" marL="3657600" indent="0" algn="l" defTabSz="914400">
-      <a:defRPr sz="1800" kern="1200">
-        <a:solidFill>
-          <a:schemeClr val="tx1"/>
-        </a:solidFill>
-        <a:latin typeface="+mn-lt"/>
-        <a:ea typeface="+mn-ea"/>
-        <a:cs typeface="+mn-cs"/>
-      </a:defRPr>
-    </a:lvl9pPr>
-  </p:defaultTextStyle>
 </p:presentation>
 </file>
 
@@ -1137,7 +1042,7 @@
   </p:cSld>
   <p:clrMap bg1="lt1" tx1="dk1" bg2="lt2" tx2="dk2" accent1="accent1" accent2="accent2" accent3="accent3" accent4="accent4" accent5="accent5" accent6="accent6" hlink="hlink" folHlink="folHlink"/>
   <p:sldLayoutIdLst>
-    <p:sldLayoutId xmlns:r="http://schemas.openxmlformats.org/officeDocument/2006/relationships" id="2147483649" r:id="R116d8a2f02824f84"/>
+    <p:sldLayoutId xmlns:r="http://schemas.openxmlformats.org/officeDocument/2006/relationships" id="2147483649" r:id="R07248c5890b44eea"/>
   </p:sldLayoutIdLst>
   <p:txStyles>
     <p:titleStyle>
@@ -1685,7 +1590,7 @@
       </p:grpSpPr>
       <p:sp>
         <p:nvSpPr>
-          <p:cNvPr id="1" name="title-accent">
+          <p:cNvPr id="9" name="title-accent">
             <a:extLst xmlns:a="http://schemas.openxmlformats.org/drawingml/2006/main">
               <a:ext uri="{FF2B5EF4-FFF2-40B4-BE49-F238E27FC236}">
                 <a16:creationId xmlns:a16="http://schemas.microsoft.com/office/drawing/2014/main" id="{28BA04A5-4F82-4449-8A1A-20C548DE42FF}"/>
@@ -1747,6 +1652,7 @@
           <a:lstStyle xmlns:a="http://schemas.openxmlformats.org/drawingml/2006/main"/>
           <a:p xmlns:a="http://schemas.openxmlformats.org/drawingml/2006/main">
             <a:pPr algn="l">
+              <a:buNone/>
               <a:defRPr sz="1125" b="1">
                 <a:solidFill>
                   <a:srgbClr val="4472C4"/>
@@ -1759,7 +1665,7 @@
                   <a:srgbClr val="4472C4"/>
                 </a:solidFill>
               </a:rPr>
-              <a:t>INTERNAL WORKING • NOT FOR EXTERNAL DISTRIBUTION</a:t>
+              <a:t>ALDER RIDGE MECHANICAL</a:t>
             </a:r>
           </a:p>
         </p:txBody>
@@ -1797,6 +1703,7 @@
           <a:lstStyle xmlns:a="http://schemas.openxmlformats.org/drawingml/2006/main"/>
           <a:p xmlns:a="http://schemas.openxmlformats.org/drawingml/2006/main">
             <a:pPr algn="l">
+              <a:buNone/>
               <a:defRPr sz="4200" b="1">
                 <a:solidFill>
                   <a:srgbClr val="17365D"/>
@@ -1814,6 +1721,7 @@
           </a:p>
           <a:p xmlns:a="http://schemas.openxmlformats.org/drawingml/2006/main">
             <a:pPr algn="l">
+              <a:buNone/>
               <a:defRPr sz="4200" b="1">
                 <a:solidFill>
                   <a:srgbClr val="17365D"/>
@@ -1864,6 +1772,7 @@
           <a:lstStyle xmlns:a="http://schemas.openxmlformats.org/drawingml/2006/main"/>
           <a:p xmlns:a="http://schemas.openxmlformats.org/drawingml/2006/main">
             <a:pPr algn="l">
+              <a:buNone/>
               <a:defRPr sz="1800" b="0">
                 <a:solidFill>
                   <a:srgbClr val="1F2937"/>
@@ -1945,6 +1854,7 @@
           <a:lstStyle xmlns:a="http://schemas.openxmlformats.org/drawingml/2006/main"/>
           <a:p xmlns:a="http://schemas.openxmlformats.org/drawingml/2006/main">
             <a:pPr algn="l">
+              <a:buNone/>
               <a:defRPr sz="1350" b="0">
                 <a:solidFill>
                   <a:srgbClr val="5B6573"/>
@@ -1995,6 +1905,7 @@
           <a:lstStyle xmlns:a="http://schemas.openxmlformats.org/drawingml/2006/main"/>
           <a:p xmlns:a="http://schemas.openxmlformats.org/drawingml/2006/main">
             <a:pPr algn="l">
+              <a:buNone/>
               <a:defRPr sz="1050" b="1">
                 <a:solidFill>
                   <a:srgbClr val="B91C1C"/>
@@ -2007,7 +1918,7 @@
                   <a:srgbClr val="B91C1C"/>
                 </a:solidFill>
               </a:rPr>
-              <a:t>Prepared for executive leadership • Working draft</a:t>
+              <a:t>Leadership review</a:t>
             </a:r>
           </a:p>
         </p:txBody>
@@ -2045,6 +1956,7 @@
           <a:lstStyle xmlns:a="http://schemas.openxmlformats.org/drawingml/2006/main"/>
           <a:p xmlns:a="http://schemas.openxmlformats.org/drawingml/2006/main">
             <a:pPr algn="r">
+              <a:buNone/>
               <a:defRPr sz="825" b="0">
                 <a:solidFill>
                   <a:srgbClr val="5B6573"/>
@@ -2093,7 +2005,7 @@
       </p:grpSpPr>
       <p:sp>
         <p:nvSpPr>
-          <p:cNvPr id="1" name="header-2">
+          <p:cNvPr id="36" name="header-2">
             <a:extLst xmlns:a="http://schemas.openxmlformats.org/drawingml/2006/main">
               <a:ext uri="{FF2B5EF4-FFF2-40B4-BE49-F238E27FC236}">
                 <a16:creationId xmlns:a16="http://schemas.microsoft.com/office/drawing/2014/main" id="{B3B0F108-ACE8-4DE3-9121-04465ADDE438}"/>
@@ -2155,6 +2067,7 @@
           <a:lstStyle xmlns:a="http://schemas.openxmlformats.org/drawingml/2006/main"/>
           <a:p xmlns:a="http://schemas.openxmlformats.org/drawingml/2006/main">
             <a:pPr algn="l">
+              <a:buNone/>
               <a:defRPr sz="2625" b="1">
                 <a:solidFill>
                   <a:srgbClr val="17365D"/>
@@ -2168,56 +2081,6 @@
                 </a:solidFill>
               </a:rPr>
               <a:t>Executive takeaways</a:t>
-            </a:r>
-          </a:p>
-        </p:txBody>
-      </p:sp>
-      <p:sp>
-        <p:nvSpPr>
-          <p:cNvPr id="3" name="draft-2">
-            <a:extLst xmlns:a="http://schemas.openxmlformats.org/drawingml/2006/main">
-              <a:ext uri="{FF2B5EF4-FFF2-40B4-BE49-F238E27FC236}">
-                <a16:creationId xmlns:a16="http://schemas.microsoft.com/office/drawing/2014/main" id="{1F9CC0E0-BF48-4279-B16F-545FE6F51963}"/>
-              </a:ext>
-            </a:extLst>
-          </p:cNvPr>
-          <p:cNvSpPr>
-            <a:spLocks xmlns:a="http://schemas.openxmlformats.org/drawingml/2006/main" noGrp="1"/>
-          </p:cNvSpPr>
-          <p:nvPr/>
-        </p:nvSpPr>
-        <p:spPr>
-          <a:xfrm xmlns:a="http://schemas.openxmlformats.org/drawingml/2006/main">
-            <a:off x="9191625" y="495300"/>
-            <a:ext cx="2381250" cy="266700"/>
-          </a:xfrm>
-          <a:prstGeom xmlns:a="http://schemas.openxmlformats.org/drawingml/2006/main" prst="rect">
-            <a:avLst/>
-          </a:prstGeom>
-          <a:noFill xmlns:a="http://schemas.openxmlformats.org/drawingml/2006/main"/>
-          <a:ln xmlns:a="http://schemas.openxmlformats.org/drawingml/2006/main" w="0">
-            <a:noFill/>
-            <a:prstDash val="solid"/>
-          </a:ln>
-        </p:spPr>
-        <p:txBody>
-          <a:bodyPr xmlns:a="http://schemas.openxmlformats.org/drawingml/2006/main" anchor="ctr"/>
-          <a:lstStyle xmlns:a="http://schemas.openxmlformats.org/drawingml/2006/main"/>
-          <a:p xmlns:a="http://schemas.openxmlformats.org/drawingml/2006/main">
-            <a:pPr algn="r">
-              <a:defRPr sz="1050" b="1">
-                <a:solidFill>
-                  <a:srgbClr val="B91C1C"/>
-                </a:solidFill>
-              </a:defRPr>
-            </a:pPr>
-            <a:r>
-              <a:rPr sz="1050" b="1">
-                <a:solidFill>
-                  <a:srgbClr val="B91C1C"/>
-                </a:solidFill>
-              </a:rPr>
-              <a:t>DRAFT — DATA NOT REFRESHED</a:t>
             </a:r>
           </a:p>
         </p:txBody>
@@ -2286,6 +2149,7 @@
           <a:lstStyle xmlns:a="http://schemas.openxmlformats.org/drawingml/2006/main"/>
           <a:p xmlns:a="http://schemas.openxmlformats.org/drawingml/2006/main">
             <a:pPr algn="l">
+              <a:buNone/>
               <a:defRPr sz="825" b="0">
                 <a:solidFill>
                   <a:srgbClr val="5B6573"/>
@@ -2298,7 +2162,7 @@
                   <a:srgbClr val="5B6573"/>
                 </a:solidFill>
               </a:rPr>
-              <a:t>Alder Ridge Mechanical • June 2026 executive performance review • Internal working</a:t>
+              <a:t>Alder Ridge Mechanical • June 2026</a:t>
             </a:r>
           </a:p>
         </p:txBody>
@@ -2336,6 +2200,7 @@
           <a:lstStyle xmlns:a="http://schemas.openxmlformats.org/drawingml/2006/main"/>
           <a:p xmlns:a="http://schemas.openxmlformats.org/drawingml/2006/main">
             <a:pPr algn="r">
+              <a:buNone/>
               <a:defRPr sz="825" b="0">
                 <a:solidFill>
                   <a:srgbClr val="5B6573"/>
@@ -2419,6 +2284,7 @@
           <a:lstStyle xmlns:a="http://schemas.openxmlformats.org/drawingml/2006/main"/>
           <a:p xmlns:a="http://schemas.openxmlformats.org/drawingml/2006/main">
             <a:pPr algn="l">
+              <a:buNone/>
               <a:defRPr sz="1050" b="1">
                 <a:solidFill>
                   <a:srgbClr val="5B6573"/>
@@ -2469,6 +2335,7 @@
           <a:lstStyle xmlns:a="http://schemas.openxmlformats.org/drawingml/2006/main"/>
           <a:p xmlns:a="http://schemas.openxmlformats.org/drawingml/2006/main">
             <a:pPr algn="l">
+              <a:buNone/>
               <a:defRPr sz="2025" b="1">
                 <a:solidFill>
                   <a:srgbClr val="17365D"/>
@@ -2552,6 +2419,7 @@
           <a:lstStyle xmlns:a="http://schemas.openxmlformats.org/drawingml/2006/main"/>
           <a:p xmlns:a="http://schemas.openxmlformats.org/drawingml/2006/main">
             <a:pPr algn="l">
+              <a:buNone/>
               <a:defRPr sz="1050" b="1">
                 <a:solidFill>
                   <a:srgbClr val="5B6573"/>
@@ -2602,6 +2470,7 @@
           <a:lstStyle xmlns:a="http://schemas.openxmlformats.org/drawingml/2006/main"/>
           <a:p xmlns:a="http://schemas.openxmlformats.org/drawingml/2006/main">
             <a:pPr algn="l">
+              <a:buNone/>
               <a:defRPr sz="2025" b="1">
                 <a:solidFill>
                   <a:srgbClr val="17365D"/>
@@ -2685,6 +2554,7 @@
           <a:lstStyle xmlns:a="http://schemas.openxmlformats.org/drawingml/2006/main"/>
           <a:p xmlns:a="http://schemas.openxmlformats.org/drawingml/2006/main">
             <a:pPr algn="l">
+              <a:buNone/>
               <a:defRPr sz="1050" b="1">
                 <a:solidFill>
                   <a:srgbClr val="5B6573"/>
@@ -2735,6 +2605,7 @@
           <a:lstStyle xmlns:a="http://schemas.openxmlformats.org/drawingml/2006/main"/>
           <a:p xmlns:a="http://schemas.openxmlformats.org/drawingml/2006/main">
             <a:pPr algn="l">
+              <a:buNone/>
               <a:defRPr sz="2025" b="1">
                 <a:solidFill>
                   <a:srgbClr val="17365D"/>
@@ -2818,6 +2689,7 @@
           <a:lstStyle xmlns:a="http://schemas.openxmlformats.org/drawingml/2006/main"/>
           <a:p xmlns:a="http://schemas.openxmlformats.org/drawingml/2006/main">
             <a:pPr algn="l">
+              <a:buNone/>
               <a:defRPr sz="1050" b="1">
                 <a:solidFill>
                   <a:srgbClr val="5B6573"/>
@@ -2868,6 +2740,7 @@
           <a:lstStyle xmlns:a="http://schemas.openxmlformats.org/drawingml/2006/main"/>
           <a:p xmlns:a="http://schemas.openxmlformats.org/drawingml/2006/main">
             <a:pPr algn="l">
+              <a:buNone/>
               <a:defRPr sz="2025" b="1">
                 <a:solidFill>
                   <a:srgbClr val="17365D"/>
@@ -2918,6 +2791,7 @@
           <a:lstStyle xmlns:a="http://schemas.openxmlformats.org/drawingml/2006/main"/>
           <a:p xmlns:a="http://schemas.openxmlformats.org/drawingml/2006/main">
             <a:pPr algn="l">
+              <a:buNone/>
               <a:defRPr sz="1650" b="1">
                 <a:solidFill>
                   <a:srgbClr val="17365D"/>
@@ -2930,7 +2804,7 @@
                   <a:srgbClr val="17365D"/>
                 </a:solidFill>
               </a:rPr>
-              <a:t>Close the loop from performance to action</a:t>
+              <a:t>Q2 performance overview</a:t>
             </a:r>
           </a:p>
         </p:txBody>
@@ -2999,6 +2873,7 @@
           <a:lstStyle xmlns:a="http://schemas.openxmlformats.org/drawingml/2006/main"/>
           <a:p xmlns:a="http://schemas.openxmlformats.org/drawingml/2006/main">
             <a:pPr algn="ctr">
+              <a:buNone/>
               <a:defRPr sz="1200" b="1">
                 <a:solidFill>
                   <a:srgbClr val="FFFFFF"/>
@@ -3049,6 +2924,7 @@
           <a:lstStyle xmlns:a="http://schemas.openxmlformats.org/drawingml/2006/main"/>
           <a:p xmlns:a="http://schemas.openxmlformats.org/drawingml/2006/main">
             <a:pPr algn="l">
+              <a:buNone/>
               <a:defRPr sz="1500" b="1">
                 <a:solidFill>
                   <a:srgbClr val="1F2937"/>
@@ -3061,7 +2937,7 @@
                   <a:srgbClr val="1F2937"/>
                 </a:solidFill>
               </a:rPr>
-              <a:t>Performance versus plan and prior year</a:t>
+              <a:t>Financial performance</a:t>
             </a:r>
           </a:p>
         </p:txBody>
@@ -3099,6 +2975,7 @@
           <a:lstStyle xmlns:a="http://schemas.openxmlformats.org/drawingml/2006/main"/>
           <a:p xmlns:a="http://schemas.openxmlformats.org/drawingml/2006/main">
             <a:pPr algn="l">
+              <a:buNone/>
               <a:defRPr sz="1200" b="0">
                 <a:solidFill>
                   <a:srgbClr val="5B6573"/>
@@ -3111,7 +2988,7 @@
                   <a:srgbClr val="5B6573"/>
                 </a:solidFill>
               </a:rPr>
-              <a:t>Complete with supported conclusion</a:t>
+              <a:t>—</a:t>
             </a:r>
           </a:p>
         </p:txBody>
@@ -3180,6 +3057,7 @@
           <a:lstStyle xmlns:a="http://schemas.openxmlformats.org/drawingml/2006/main"/>
           <a:p xmlns:a="http://schemas.openxmlformats.org/drawingml/2006/main">
             <a:pPr algn="ctr">
+              <a:buNone/>
               <a:defRPr sz="1200" b="1">
                 <a:solidFill>
                   <a:srgbClr val="FFFFFF"/>
@@ -3230,6 +3108,7 @@
           <a:lstStyle xmlns:a="http://schemas.openxmlformats.org/drawingml/2006/main"/>
           <a:p xmlns:a="http://schemas.openxmlformats.org/drawingml/2006/main">
             <a:pPr algn="l">
+              <a:buNone/>
               <a:defRPr sz="1500" b="0">
                 <a:solidFill>
                   <a:srgbClr val="1F2937"/>
@@ -3242,7 +3121,7 @@
                   <a:srgbClr val="1F2937"/>
                 </a:solidFill>
               </a:rPr>
-              <a:t>Primary operating causes</a:t>
+              <a:t>Operating performance</a:t>
             </a:r>
           </a:p>
         </p:txBody>
@@ -3280,6 +3159,7 @@
           <a:lstStyle xmlns:a="http://schemas.openxmlformats.org/drawingml/2006/main"/>
           <a:p xmlns:a="http://schemas.openxmlformats.org/drawingml/2006/main">
             <a:pPr algn="l">
+              <a:buNone/>
               <a:defRPr sz="1200" b="0">
                 <a:solidFill>
                   <a:srgbClr val="5B6573"/>
@@ -3292,7 +3172,7 @@
                   <a:srgbClr val="5B6573"/>
                 </a:solidFill>
               </a:rPr>
-              <a:t>Complete with supported conclusion</a:t>
+              <a:t>—</a:t>
             </a:r>
           </a:p>
         </p:txBody>
@@ -3361,6 +3241,7 @@
           <a:lstStyle xmlns:a="http://schemas.openxmlformats.org/drawingml/2006/main"/>
           <a:p xmlns:a="http://schemas.openxmlformats.org/drawingml/2006/main">
             <a:pPr algn="ctr">
+              <a:buNone/>
               <a:defRPr sz="1200" b="1">
                 <a:solidFill>
                   <a:srgbClr val="FFFFFF"/>
@@ -3411,6 +3292,7 @@
           <a:lstStyle xmlns:a="http://schemas.openxmlformats.org/drawingml/2006/main"/>
           <a:p xmlns:a="http://schemas.openxmlformats.org/drawingml/2006/main">
             <a:pPr algn="l">
+              <a:buNone/>
               <a:defRPr sz="1500" b="0">
                 <a:solidFill>
                   <a:srgbClr val="1F2937"/>
@@ -3423,7 +3305,7 @@
                   <a:srgbClr val="1F2937"/>
                 </a:solidFill>
               </a:rPr>
-              <a:t>Liquidity and covenant posture</a:t>
+              <a:t>Cash and liquidity</a:t>
             </a:r>
           </a:p>
         </p:txBody>
@@ -3461,6 +3343,7 @@
           <a:lstStyle xmlns:a="http://schemas.openxmlformats.org/drawingml/2006/main"/>
           <a:p xmlns:a="http://schemas.openxmlformats.org/drawingml/2006/main">
             <a:pPr algn="l">
+              <a:buNone/>
               <a:defRPr sz="1200" b="0">
                 <a:solidFill>
                   <a:srgbClr val="5B6573"/>
@@ -3473,7 +3356,7 @@
                   <a:srgbClr val="5B6573"/>
                 </a:solidFill>
               </a:rPr>
-              <a:t>Complete with supported conclusion</a:t>
+              <a:t>—</a:t>
             </a:r>
           </a:p>
         </p:txBody>
@@ -3542,6 +3425,7 @@
           <a:lstStyle xmlns:a="http://schemas.openxmlformats.org/drawingml/2006/main"/>
           <a:p xmlns:a="http://schemas.openxmlformats.org/drawingml/2006/main">
             <a:pPr algn="ctr">
+              <a:buNone/>
               <a:defRPr sz="1200" b="1">
                 <a:solidFill>
                   <a:srgbClr val="FFFFFF"/>
@@ -3592,6 +3476,7 @@
           <a:lstStyle xmlns:a="http://schemas.openxmlformats.org/drawingml/2006/main"/>
           <a:p xmlns:a="http://schemas.openxmlformats.org/drawingml/2006/main">
             <a:pPr algn="l">
+              <a:buNone/>
               <a:defRPr sz="1500" b="0">
                 <a:solidFill>
                   <a:srgbClr val="1F2937"/>
@@ -3604,7 +3489,7 @@
                   <a:srgbClr val="1F2937"/>
                 </a:solidFill>
               </a:rPr>
-              <a:t>Actions, owners, and decision dates</a:t>
+              <a:t>Management actions</a:t>
             </a:r>
           </a:p>
         </p:txBody>
@@ -3642,6 +3527,7 @@
           <a:lstStyle xmlns:a="http://schemas.openxmlformats.org/drawingml/2006/main"/>
           <a:p xmlns:a="http://schemas.openxmlformats.org/drawingml/2006/main">
             <a:pPr algn="l">
+              <a:buNone/>
               <a:defRPr sz="1200" b="0">
                 <a:solidFill>
                   <a:srgbClr val="5B6573"/>
@@ -3654,7 +3540,7 @@
                   <a:srgbClr val="5B6573"/>
                 </a:solidFill>
               </a:rPr>
-              <a:t>Complete with supported conclusion</a:t>
+              <a:t>—</a:t>
             </a:r>
           </a:p>
         </p:txBody>
@@ -3690,7 +3576,7 @@
       </p:grpSpPr>
       <p:sp>
         <p:nvSpPr>
-          <p:cNvPr id="1" name="header-3">
+          <p:cNvPr id="39" name="header-3">
             <a:extLst xmlns:a="http://schemas.openxmlformats.org/drawingml/2006/main">
               <a:ext uri="{FF2B5EF4-FFF2-40B4-BE49-F238E27FC236}">
                 <a16:creationId xmlns:a16="http://schemas.microsoft.com/office/drawing/2014/main" id="{27F9500E-ADFC-47C2-9685-BC06E22C532A}"/>
@@ -3752,6 +3638,7 @@
           <a:lstStyle xmlns:a="http://schemas.openxmlformats.org/drawingml/2006/main"/>
           <a:p xmlns:a="http://schemas.openxmlformats.org/drawingml/2006/main">
             <a:pPr algn="l">
+              <a:buNone/>
               <a:defRPr sz="2625" b="1">
                 <a:solidFill>
                   <a:srgbClr val="17365D"/>
@@ -3764,57 +3651,7 @@
                   <a:srgbClr val="17365D"/>
                 </a:solidFill>
               </a:rPr>
-              <a:t>Revenue: bridge plan to actual before resetting the outlook</a:t>
-            </a:r>
-          </a:p>
-        </p:txBody>
-      </p:sp>
-      <p:sp>
-        <p:nvSpPr>
-          <p:cNvPr id="3" name="draft-3">
-            <a:extLst xmlns:a="http://schemas.openxmlformats.org/drawingml/2006/main">
-              <a:ext uri="{FF2B5EF4-FFF2-40B4-BE49-F238E27FC236}">
-                <a16:creationId xmlns:a16="http://schemas.microsoft.com/office/drawing/2014/main" id="{D0140804-47FD-47CB-B060-893B260E708A}"/>
-              </a:ext>
-            </a:extLst>
-          </p:cNvPr>
-          <p:cNvSpPr>
-            <a:spLocks xmlns:a="http://schemas.openxmlformats.org/drawingml/2006/main" noGrp="1"/>
-          </p:cNvSpPr>
-          <p:nvPr/>
-        </p:nvSpPr>
-        <p:spPr>
-          <a:xfrm xmlns:a="http://schemas.openxmlformats.org/drawingml/2006/main">
-            <a:off x="9191625" y="495300"/>
-            <a:ext cx="2381250" cy="266700"/>
-          </a:xfrm>
-          <a:prstGeom xmlns:a="http://schemas.openxmlformats.org/drawingml/2006/main" prst="rect">
-            <a:avLst/>
-          </a:prstGeom>
-          <a:noFill xmlns:a="http://schemas.openxmlformats.org/drawingml/2006/main"/>
-          <a:ln xmlns:a="http://schemas.openxmlformats.org/drawingml/2006/main" w="0">
-            <a:noFill/>
-            <a:prstDash val="solid"/>
-          </a:ln>
-        </p:spPr>
-        <p:txBody>
-          <a:bodyPr xmlns:a="http://schemas.openxmlformats.org/drawingml/2006/main" anchor="ctr"/>
-          <a:lstStyle xmlns:a="http://schemas.openxmlformats.org/drawingml/2006/main"/>
-          <a:p xmlns:a="http://schemas.openxmlformats.org/drawingml/2006/main">
-            <a:pPr algn="r">
-              <a:defRPr sz="1050" b="1">
-                <a:solidFill>
-                  <a:srgbClr val="B91C1C"/>
-                </a:solidFill>
-              </a:defRPr>
-            </a:pPr>
-            <a:r>
-              <a:rPr sz="1050" b="1">
-                <a:solidFill>
-                  <a:srgbClr val="B91C1C"/>
-                </a:solidFill>
-              </a:rPr>
-              <a:t>DRAFT — DATA NOT REFRESHED</a:t>
+              <a:t>Revenue performance</a:t>
             </a:r>
           </a:p>
         </p:txBody>
@@ -3883,6 +3720,7 @@
           <a:lstStyle xmlns:a="http://schemas.openxmlformats.org/drawingml/2006/main"/>
           <a:p xmlns:a="http://schemas.openxmlformats.org/drawingml/2006/main">
             <a:pPr algn="l">
+              <a:buNone/>
               <a:defRPr sz="825" b="0">
                 <a:solidFill>
                   <a:srgbClr val="5B6573"/>
@@ -3895,7 +3733,7 @@
                   <a:srgbClr val="5B6573"/>
                 </a:solidFill>
               </a:rPr>
-              <a:t>Alder Ridge Mechanical • June 2026 executive performance review • Internal working</a:t>
+              <a:t>Alder Ridge Mechanical • June 2026</a:t>
             </a:r>
           </a:p>
         </p:txBody>
@@ -3933,6 +3771,7 @@
           <a:lstStyle xmlns:a="http://schemas.openxmlformats.org/drawingml/2006/main"/>
           <a:p xmlns:a="http://schemas.openxmlformats.org/drawingml/2006/main">
             <a:pPr algn="r">
+              <a:buNone/>
               <a:defRPr sz="825" b="0">
                 <a:solidFill>
                   <a:srgbClr val="5B6573"/>
@@ -4016,6 +3855,7 @@
           <a:lstStyle xmlns:a="http://schemas.openxmlformats.org/drawingml/2006/main"/>
           <a:p xmlns:a="http://schemas.openxmlformats.org/drawingml/2006/main">
             <a:pPr algn="l">
+              <a:buNone/>
               <a:defRPr sz="1050" b="1">
                 <a:solidFill>
                   <a:srgbClr val="5B6573"/>
@@ -4066,6 +3906,7 @@
           <a:lstStyle xmlns:a="http://schemas.openxmlformats.org/drawingml/2006/main"/>
           <a:p xmlns:a="http://schemas.openxmlformats.org/drawingml/2006/main">
             <a:pPr algn="l">
+              <a:buNone/>
               <a:defRPr sz="2025" b="1">
                 <a:solidFill>
                   <a:srgbClr val="17365D"/>
@@ -4149,6 +3990,7 @@
           <a:lstStyle xmlns:a="http://schemas.openxmlformats.org/drawingml/2006/main"/>
           <a:p xmlns:a="http://schemas.openxmlformats.org/drawingml/2006/main">
             <a:pPr algn="l">
+              <a:buNone/>
               <a:defRPr sz="1050" b="1">
                 <a:solidFill>
                   <a:srgbClr val="5B6573"/>
@@ -4199,6 +4041,7 @@
           <a:lstStyle xmlns:a="http://schemas.openxmlformats.org/drawingml/2006/main"/>
           <a:p xmlns:a="http://schemas.openxmlformats.org/drawingml/2006/main">
             <a:pPr algn="l">
+              <a:buNone/>
               <a:defRPr sz="2025" b="1">
                 <a:solidFill>
                   <a:srgbClr val="17365D"/>
@@ -4282,6 +4125,7 @@
           <a:lstStyle xmlns:a="http://schemas.openxmlformats.org/drawingml/2006/main"/>
           <a:p xmlns:a="http://schemas.openxmlformats.org/drawingml/2006/main">
             <a:pPr algn="l">
+              <a:buNone/>
               <a:defRPr sz="1050" b="1">
                 <a:solidFill>
                   <a:srgbClr val="5B6573"/>
@@ -4332,6 +4176,7 @@
           <a:lstStyle xmlns:a="http://schemas.openxmlformats.org/drawingml/2006/main"/>
           <a:p xmlns:a="http://schemas.openxmlformats.org/drawingml/2006/main">
             <a:pPr algn="l">
+              <a:buNone/>
               <a:defRPr sz="2025" b="1">
                 <a:solidFill>
                   <a:srgbClr val="17365D"/>
@@ -4415,6 +4260,7 @@
           <a:lstStyle xmlns:a="http://schemas.openxmlformats.org/drawingml/2006/main"/>
           <a:p xmlns:a="http://schemas.openxmlformats.org/drawingml/2006/main">
             <a:pPr algn="l">
+              <a:buNone/>
               <a:defRPr sz="1050" b="1">
                 <a:solidFill>
                   <a:srgbClr val="5B6573"/>
@@ -4465,6 +4311,7 @@
           <a:lstStyle xmlns:a="http://schemas.openxmlformats.org/drawingml/2006/main"/>
           <a:p xmlns:a="http://schemas.openxmlformats.org/drawingml/2006/main">
             <a:pPr algn="l">
+              <a:buNone/>
               <a:defRPr sz="2025" b="1">
                 <a:solidFill>
                   <a:srgbClr val="17365D"/>
@@ -4515,6 +4362,7 @@
           <a:lstStyle xmlns:a="http://schemas.openxmlformats.org/drawingml/2006/main"/>
           <a:p xmlns:a="http://schemas.openxmlformats.org/drawingml/2006/main">
             <a:pPr algn="l">
+              <a:buNone/>
               <a:defRPr sz="1650" b="1">
                 <a:solidFill>
                   <a:srgbClr val="17365D"/>
@@ -4598,6 +4446,7 @@
           <a:lstStyle xmlns:a="http://schemas.openxmlformats.org/drawingml/2006/main"/>
           <a:p xmlns:a="http://schemas.openxmlformats.org/drawingml/2006/main">
             <a:pPr algn="ctr">
+              <a:buNone/>
               <a:defRPr sz="1200" b="1">
                 <a:solidFill>
                   <a:srgbClr val="1F2937"/>
@@ -4648,6 +4497,7 @@
           <a:lstStyle xmlns:a="http://schemas.openxmlformats.org/drawingml/2006/main"/>
           <a:p xmlns:a="http://schemas.openxmlformats.org/drawingml/2006/main">
             <a:pPr algn="ctr">
+              <a:buNone/>
               <a:defRPr sz="1650" b="1">
                 <a:solidFill>
                   <a:srgbClr val="FFFFFF"/>
@@ -4731,6 +4581,7 @@
           <a:lstStyle xmlns:a="http://schemas.openxmlformats.org/drawingml/2006/main"/>
           <a:p xmlns:a="http://schemas.openxmlformats.org/drawingml/2006/main">
             <a:pPr algn="ctr">
+              <a:buNone/>
               <a:defRPr sz="1200" b="0">
                 <a:solidFill>
                   <a:srgbClr val="1F2937"/>
@@ -4743,7 +4594,7 @@
                   <a:srgbClr val="1F2937"/>
                 </a:solidFill>
               </a:rPr>
-              <a:t>Volume</a:t>
+              <a:t>Change 1</a:t>
             </a:r>
           </a:p>
         </p:txBody>
@@ -4781,6 +4632,7 @@
           <a:lstStyle xmlns:a="http://schemas.openxmlformats.org/drawingml/2006/main"/>
           <a:p xmlns:a="http://schemas.openxmlformats.org/drawingml/2006/main">
             <a:pPr algn="ctr">
+              <a:buNone/>
               <a:defRPr sz="1650" b="1">
                 <a:solidFill>
                   <a:srgbClr val="17365D"/>
@@ -4864,6 +4716,7 @@
           <a:lstStyle xmlns:a="http://schemas.openxmlformats.org/drawingml/2006/main"/>
           <a:p xmlns:a="http://schemas.openxmlformats.org/drawingml/2006/main">
             <a:pPr algn="ctr">
+              <a:buNone/>
               <a:defRPr sz="1200" b="0">
                 <a:solidFill>
                   <a:srgbClr val="1F2937"/>
@@ -4876,7 +4729,7 @@
                   <a:srgbClr val="1F2937"/>
                 </a:solidFill>
               </a:rPr>
-              <a:t>Price</a:t>
+              <a:t>Change 2</a:t>
             </a:r>
           </a:p>
         </p:txBody>
@@ -4914,6 +4767,7 @@
           <a:lstStyle xmlns:a="http://schemas.openxmlformats.org/drawingml/2006/main"/>
           <a:p xmlns:a="http://schemas.openxmlformats.org/drawingml/2006/main">
             <a:pPr algn="ctr">
+              <a:buNone/>
               <a:defRPr sz="1650" b="1">
                 <a:solidFill>
                   <a:srgbClr val="17365D"/>
@@ -4997,6 +4851,7 @@
           <a:lstStyle xmlns:a="http://schemas.openxmlformats.org/drawingml/2006/main"/>
           <a:p xmlns:a="http://schemas.openxmlformats.org/drawingml/2006/main">
             <a:pPr algn="ctr">
+              <a:buNone/>
               <a:defRPr sz="1200" b="0">
                 <a:solidFill>
                   <a:srgbClr val="1F2937"/>
@@ -5009,7 +4864,7 @@
                   <a:srgbClr val="1F2937"/>
                 </a:solidFill>
               </a:rPr>
-              <a:t>Mix</a:t>
+              <a:t>Change 3</a:t>
             </a:r>
           </a:p>
         </p:txBody>
@@ -5047,6 +4902,7 @@
           <a:lstStyle xmlns:a="http://schemas.openxmlformats.org/drawingml/2006/main"/>
           <a:p xmlns:a="http://schemas.openxmlformats.org/drawingml/2006/main">
             <a:pPr algn="ctr">
+              <a:buNone/>
               <a:defRPr sz="1650" b="1">
                 <a:solidFill>
                   <a:srgbClr val="17365D"/>
@@ -5130,6 +4986,7 @@
           <a:lstStyle xmlns:a="http://schemas.openxmlformats.org/drawingml/2006/main"/>
           <a:p xmlns:a="http://schemas.openxmlformats.org/drawingml/2006/main">
             <a:pPr algn="ctr">
+              <a:buNone/>
               <a:defRPr sz="1200" b="0">
                 <a:solidFill>
                   <a:srgbClr val="1F2937"/>
@@ -5142,7 +4999,7 @@
                   <a:srgbClr val="1F2937"/>
                 </a:solidFill>
               </a:rPr>
-              <a:t>Backlog timing</a:t>
+              <a:t>Other</a:t>
             </a:r>
           </a:p>
         </p:txBody>
@@ -5180,6 +5037,7 @@
           <a:lstStyle xmlns:a="http://schemas.openxmlformats.org/drawingml/2006/main"/>
           <a:p xmlns:a="http://schemas.openxmlformats.org/drawingml/2006/main">
             <a:pPr algn="ctr">
+              <a:buNone/>
               <a:defRPr sz="1650" b="1">
                 <a:solidFill>
                   <a:srgbClr val="17365D"/>
@@ -5263,6 +5121,7 @@
           <a:lstStyle xmlns:a="http://schemas.openxmlformats.org/drawingml/2006/main"/>
           <a:p xmlns:a="http://schemas.openxmlformats.org/drawingml/2006/main">
             <a:pPr algn="ctr">
+              <a:buNone/>
               <a:defRPr sz="1200" b="1">
                 <a:solidFill>
                   <a:srgbClr val="1F2937"/>
@@ -5313,6 +5172,7 @@
           <a:lstStyle xmlns:a="http://schemas.openxmlformats.org/drawingml/2006/main"/>
           <a:p xmlns:a="http://schemas.openxmlformats.org/drawingml/2006/main">
             <a:pPr algn="ctr">
+              <a:buNone/>
               <a:defRPr sz="1650" b="1">
                 <a:solidFill>
                   <a:srgbClr val="FFFFFF"/>
@@ -5363,6 +5223,7 @@
           <a:lstStyle xmlns:a="http://schemas.openxmlformats.org/drawingml/2006/main"/>
           <a:p xmlns:a="http://schemas.openxmlformats.org/drawingml/2006/main">
             <a:pPr algn="l">
+              <a:buNone/>
               <a:defRPr sz="900" b="0">
                 <a:solidFill>
                   <a:srgbClr val="5B6573"/>
@@ -5375,7 +5236,7 @@
                   <a:srgbClr val="5B6573"/>
                 </a:solidFill>
               </a:rPr>
-              <a:t>Source: controller-reviewed reporting schedules, management correspondence, and Vista ERP</a:t>
+              <a:t>Source:</a:t>
             </a:r>
           </a:p>
         </p:txBody>
@@ -5411,7 +5272,7 @@
       </p:grpSpPr>
       <p:sp>
         <p:nvSpPr>
-          <p:cNvPr id="1" name="header-4">
+          <p:cNvPr id="38" name="header-4">
             <a:extLst xmlns:a="http://schemas.openxmlformats.org/drawingml/2006/main">
               <a:ext uri="{FF2B5EF4-FFF2-40B4-BE49-F238E27FC236}">
                 <a16:creationId xmlns:a16="http://schemas.microsoft.com/office/drawing/2014/main" id="{1DB38802-DF8F-4D11-AFC0-84B0F03741A5}"/>
@@ -5473,6 +5334,7 @@
           <a:lstStyle xmlns:a="http://schemas.openxmlformats.org/drawingml/2006/main"/>
           <a:p xmlns:a="http://schemas.openxmlformats.org/drawingml/2006/main">
             <a:pPr algn="l">
+              <a:buNone/>
               <a:defRPr sz="2625" b="1">
                 <a:solidFill>
                   <a:srgbClr val="17365D"/>
@@ -5485,57 +5347,7 @@
                   <a:srgbClr val="17365D"/>
                 </a:solidFill>
               </a:rPr>
-              <a:t>EBITDA: isolate operational drivers from one-time items</a:t>
-            </a:r>
-          </a:p>
-        </p:txBody>
-      </p:sp>
-      <p:sp>
-        <p:nvSpPr>
-          <p:cNvPr id="3" name="draft-4">
-            <a:extLst xmlns:a="http://schemas.openxmlformats.org/drawingml/2006/main">
-              <a:ext uri="{FF2B5EF4-FFF2-40B4-BE49-F238E27FC236}">
-                <a16:creationId xmlns:a16="http://schemas.microsoft.com/office/drawing/2014/main" id="{C703CC8B-4DAB-4BFA-A478-0EB614E1423D}"/>
-              </a:ext>
-            </a:extLst>
-          </p:cNvPr>
-          <p:cNvSpPr>
-            <a:spLocks xmlns:a="http://schemas.openxmlformats.org/drawingml/2006/main" noGrp="1"/>
-          </p:cNvSpPr>
-          <p:nvPr/>
-        </p:nvSpPr>
-        <p:spPr>
-          <a:xfrm xmlns:a="http://schemas.openxmlformats.org/drawingml/2006/main">
-            <a:off x="9191625" y="495300"/>
-            <a:ext cx="2381250" cy="266700"/>
-          </a:xfrm>
-          <a:prstGeom xmlns:a="http://schemas.openxmlformats.org/drawingml/2006/main" prst="rect">
-            <a:avLst/>
-          </a:prstGeom>
-          <a:noFill xmlns:a="http://schemas.openxmlformats.org/drawingml/2006/main"/>
-          <a:ln xmlns:a="http://schemas.openxmlformats.org/drawingml/2006/main" w="0">
-            <a:noFill/>
-            <a:prstDash val="solid"/>
-          </a:ln>
-        </p:spPr>
-        <p:txBody>
-          <a:bodyPr xmlns:a="http://schemas.openxmlformats.org/drawingml/2006/main" anchor="ctr"/>
-          <a:lstStyle xmlns:a="http://schemas.openxmlformats.org/drawingml/2006/main"/>
-          <a:p xmlns:a="http://schemas.openxmlformats.org/drawingml/2006/main">
-            <a:pPr algn="r">
-              <a:defRPr sz="1050" b="1">
-                <a:solidFill>
-                  <a:srgbClr val="B91C1C"/>
-                </a:solidFill>
-              </a:defRPr>
-            </a:pPr>
-            <a:r>
-              <a:rPr sz="1050" b="1">
-                <a:solidFill>
-                  <a:srgbClr val="B91C1C"/>
-                </a:solidFill>
-              </a:rPr>
-              <a:t>DRAFT — DATA NOT REFRESHED</a:t>
+              <a:t>Adjusted EBITDA performance</a:t>
             </a:r>
           </a:p>
         </p:txBody>
@@ -5604,6 +5416,7 @@
           <a:lstStyle xmlns:a="http://schemas.openxmlformats.org/drawingml/2006/main"/>
           <a:p xmlns:a="http://schemas.openxmlformats.org/drawingml/2006/main">
             <a:pPr algn="l">
+              <a:buNone/>
               <a:defRPr sz="825" b="0">
                 <a:solidFill>
                   <a:srgbClr val="5B6573"/>
@@ -5616,7 +5429,7 @@
                   <a:srgbClr val="5B6573"/>
                 </a:solidFill>
               </a:rPr>
-              <a:t>Alder Ridge Mechanical • June 2026 executive performance review • Internal working</a:t>
+              <a:t>Alder Ridge Mechanical • June 2026</a:t>
             </a:r>
           </a:p>
         </p:txBody>
@@ -5654,6 +5467,7 @@
           <a:lstStyle xmlns:a="http://schemas.openxmlformats.org/drawingml/2006/main"/>
           <a:p xmlns:a="http://schemas.openxmlformats.org/drawingml/2006/main">
             <a:pPr algn="r">
+              <a:buNone/>
               <a:defRPr sz="825" b="0">
                 <a:solidFill>
                   <a:srgbClr val="5B6573"/>
@@ -5737,6 +5551,7 @@
           <a:lstStyle xmlns:a="http://schemas.openxmlformats.org/drawingml/2006/main"/>
           <a:p xmlns:a="http://schemas.openxmlformats.org/drawingml/2006/main">
             <a:pPr algn="l">
+              <a:buNone/>
               <a:defRPr sz="1050" b="1">
                 <a:solidFill>
                   <a:srgbClr val="5B6573"/>
@@ -5787,6 +5602,7 @@
           <a:lstStyle xmlns:a="http://schemas.openxmlformats.org/drawingml/2006/main"/>
           <a:p xmlns:a="http://schemas.openxmlformats.org/drawingml/2006/main">
             <a:pPr algn="l">
+              <a:buNone/>
               <a:defRPr sz="2025" b="1">
                 <a:solidFill>
                   <a:srgbClr val="17365D"/>
@@ -5870,6 +5686,7 @@
           <a:lstStyle xmlns:a="http://schemas.openxmlformats.org/drawingml/2006/main"/>
           <a:p xmlns:a="http://schemas.openxmlformats.org/drawingml/2006/main">
             <a:pPr algn="l">
+              <a:buNone/>
               <a:defRPr sz="1050" b="1">
                 <a:solidFill>
                   <a:srgbClr val="5B6573"/>
@@ -5920,6 +5737,7 @@
           <a:lstStyle xmlns:a="http://schemas.openxmlformats.org/drawingml/2006/main"/>
           <a:p xmlns:a="http://schemas.openxmlformats.org/drawingml/2006/main">
             <a:pPr algn="l">
+              <a:buNone/>
               <a:defRPr sz="2025" b="1">
                 <a:solidFill>
                   <a:srgbClr val="17365D"/>
@@ -6003,6 +5821,7 @@
           <a:lstStyle xmlns:a="http://schemas.openxmlformats.org/drawingml/2006/main"/>
           <a:p xmlns:a="http://schemas.openxmlformats.org/drawingml/2006/main">
             <a:pPr algn="l">
+              <a:buNone/>
               <a:defRPr sz="1050" b="1">
                 <a:solidFill>
                   <a:srgbClr val="5B6573"/>
@@ -6053,6 +5872,7 @@
           <a:lstStyle xmlns:a="http://schemas.openxmlformats.org/drawingml/2006/main"/>
           <a:p xmlns:a="http://schemas.openxmlformats.org/drawingml/2006/main">
             <a:pPr algn="l">
+              <a:buNone/>
               <a:defRPr sz="2025" b="1">
                 <a:solidFill>
                   <a:srgbClr val="17365D"/>
@@ -6136,6 +5956,7 @@
           <a:lstStyle xmlns:a="http://schemas.openxmlformats.org/drawingml/2006/main"/>
           <a:p xmlns:a="http://schemas.openxmlformats.org/drawingml/2006/main">
             <a:pPr algn="l">
+              <a:buNone/>
               <a:defRPr sz="1050" b="1">
                 <a:solidFill>
                   <a:srgbClr val="5B6573"/>
@@ -6186,6 +6007,7 @@
           <a:lstStyle xmlns:a="http://schemas.openxmlformats.org/drawingml/2006/main"/>
           <a:p xmlns:a="http://schemas.openxmlformats.org/drawingml/2006/main">
             <a:pPr algn="l">
+              <a:buNone/>
               <a:defRPr sz="2025" b="1">
                 <a:solidFill>
                   <a:srgbClr val="17365D"/>
@@ -6236,6 +6058,7 @@
           <a:lstStyle xmlns:a="http://schemas.openxmlformats.org/drawingml/2006/main"/>
           <a:p xmlns:a="http://schemas.openxmlformats.org/drawingml/2006/main">
             <a:pPr algn="l">
+              <a:buNone/>
               <a:defRPr sz="1650" b="1">
                 <a:solidFill>
                   <a:srgbClr val="17365D"/>
@@ -6319,6 +6142,7 @@
           <a:lstStyle xmlns:a="http://schemas.openxmlformats.org/drawingml/2006/main"/>
           <a:p xmlns:a="http://schemas.openxmlformats.org/drawingml/2006/main">
             <a:pPr algn="ctr">
+              <a:buNone/>
               <a:defRPr sz="1125" b="1">
                 <a:solidFill>
                   <a:srgbClr val="1F2937"/>
@@ -6369,6 +6193,7 @@
           <a:lstStyle xmlns:a="http://schemas.openxmlformats.org/drawingml/2006/main"/>
           <a:p xmlns:a="http://schemas.openxmlformats.org/drawingml/2006/main">
             <a:pPr algn="ctr">
+              <a:buNone/>
               <a:defRPr sz="1650" b="1">
                 <a:solidFill>
                   <a:srgbClr val="FFFFFF"/>
@@ -6452,6 +6277,7 @@
           <a:lstStyle xmlns:a="http://schemas.openxmlformats.org/drawingml/2006/main"/>
           <a:p xmlns:a="http://schemas.openxmlformats.org/drawingml/2006/main">
             <a:pPr algn="ctr">
+              <a:buNone/>
               <a:defRPr sz="1125" b="0">
                 <a:solidFill>
                   <a:srgbClr val="1F2937"/>
@@ -6464,7 +6290,7 @@
                   <a:srgbClr val="1F2937"/>
                 </a:solidFill>
               </a:rPr>
-              <a:t>Revenue / mix</a:t>
+              <a:t>Change 1</a:t>
             </a:r>
           </a:p>
         </p:txBody>
@@ -6502,6 +6328,7 @@
           <a:lstStyle xmlns:a="http://schemas.openxmlformats.org/drawingml/2006/main"/>
           <a:p xmlns:a="http://schemas.openxmlformats.org/drawingml/2006/main">
             <a:pPr algn="ctr">
+              <a:buNone/>
               <a:defRPr sz="1650" b="1">
                 <a:solidFill>
                   <a:srgbClr val="17365D"/>
@@ -6585,6 +6412,7 @@
           <a:lstStyle xmlns:a="http://schemas.openxmlformats.org/drawingml/2006/main"/>
           <a:p xmlns:a="http://schemas.openxmlformats.org/drawingml/2006/main">
             <a:pPr algn="ctr">
+              <a:buNone/>
               <a:defRPr sz="1125" b="0">
                 <a:solidFill>
                   <a:srgbClr val="1F2937"/>
@@ -6597,7 +6425,7 @@
                   <a:srgbClr val="1F2937"/>
                 </a:solidFill>
               </a:rPr>
-              <a:t>Field labor</a:t>
+              <a:t>Change 2</a:t>
             </a:r>
           </a:p>
         </p:txBody>
@@ -6635,6 +6463,7 @@
           <a:lstStyle xmlns:a="http://schemas.openxmlformats.org/drawingml/2006/main"/>
           <a:p xmlns:a="http://schemas.openxmlformats.org/drawingml/2006/main">
             <a:pPr algn="ctr">
+              <a:buNone/>
               <a:defRPr sz="1650" b="1">
                 <a:solidFill>
                   <a:srgbClr val="17365D"/>
@@ -6718,6 +6547,7 @@
           <a:lstStyle xmlns:a="http://schemas.openxmlformats.org/drawingml/2006/main"/>
           <a:p xmlns:a="http://schemas.openxmlformats.org/drawingml/2006/main">
             <a:pPr algn="ctr">
+              <a:buNone/>
               <a:defRPr sz="1125" b="0">
                 <a:solidFill>
                   <a:srgbClr val="1F2937"/>
@@ -6730,7 +6560,7 @@
                   <a:srgbClr val="1F2937"/>
                 </a:solidFill>
               </a:rPr>
-              <a:t>Materials</a:t>
+              <a:t>Change 3</a:t>
             </a:r>
           </a:p>
         </p:txBody>
@@ -6768,6 +6598,7 @@
           <a:lstStyle xmlns:a="http://schemas.openxmlformats.org/drawingml/2006/main"/>
           <a:p xmlns:a="http://schemas.openxmlformats.org/drawingml/2006/main">
             <a:pPr algn="ctr">
+              <a:buNone/>
               <a:defRPr sz="1650" b="1">
                 <a:solidFill>
                   <a:srgbClr val="17365D"/>
@@ -6851,6 +6682,7 @@
           <a:lstStyle xmlns:a="http://schemas.openxmlformats.org/drawingml/2006/main"/>
           <a:p xmlns:a="http://schemas.openxmlformats.org/drawingml/2006/main">
             <a:pPr algn="ctr">
+              <a:buNone/>
               <a:defRPr sz="1125" b="0">
                 <a:solidFill>
                   <a:srgbClr val="1F2937"/>
@@ -6863,7 +6695,7 @@
                   <a:srgbClr val="1F2937"/>
                 </a:solidFill>
               </a:rPr>
-              <a:t>Overhead</a:t>
+              <a:t>Other</a:t>
             </a:r>
           </a:p>
         </p:txBody>
@@ -6901,6 +6733,7 @@
           <a:lstStyle xmlns:a="http://schemas.openxmlformats.org/drawingml/2006/main"/>
           <a:p xmlns:a="http://schemas.openxmlformats.org/drawingml/2006/main">
             <a:pPr algn="ctr">
+              <a:buNone/>
               <a:defRPr sz="1650" b="1">
                 <a:solidFill>
                   <a:srgbClr val="17365D"/>
@@ -6984,6 +6817,7 @@
           <a:lstStyle xmlns:a="http://schemas.openxmlformats.org/drawingml/2006/main"/>
           <a:p xmlns:a="http://schemas.openxmlformats.org/drawingml/2006/main">
             <a:pPr algn="ctr">
+              <a:buNone/>
               <a:defRPr sz="1125" b="1">
                 <a:solidFill>
                   <a:srgbClr val="1F2937"/>
@@ -7034,6 +6868,7 @@
           <a:lstStyle xmlns:a="http://schemas.openxmlformats.org/drawingml/2006/main"/>
           <a:p xmlns:a="http://schemas.openxmlformats.org/drawingml/2006/main">
             <a:pPr algn="ctr">
+              <a:buNone/>
               <a:defRPr sz="1650" b="1">
                 <a:solidFill>
                   <a:srgbClr val="FFFFFF"/>
@@ -7082,7 +6917,7 @@
       </p:grpSpPr>
       <p:sp>
         <p:nvSpPr>
-          <p:cNvPr id="1" name="header-5">
+          <p:cNvPr id="91" name="header-5">
             <a:extLst xmlns:a="http://schemas.openxmlformats.org/drawingml/2006/main">
               <a:ext uri="{FF2B5EF4-FFF2-40B4-BE49-F238E27FC236}">
                 <a16:creationId xmlns:a16="http://schemas.microsoft.com/office/drawing/2014/main" id="{77AF888A-DF0B-4D88-AB51-D16FE9D3D34E}"/>
@@ -7144,6 +6979,7 @@
           <a:lstStyle xmlns:a="http://schemas.openxmlformats.org/drawingml/2006/main"/>
           <a:p xmlns:a="http://schemas.openxmlformats.org/drawingml/2006/main">
             <a:pPr algn="l">
+              <a:buNone/>
               <a:defRPr sz="2625" b="1">
                 <a:solidFill>
                   <a:srgbClr val="17365D"/>
@@ -7156,57 +6992,7 @@
                   <a:srgbClr val="17365D"/>
                 </a:solidFill>
               </a:rPr>
-              <a:t>Business-unit scorecard: make the misses and owners explicit</a:t>
-            </a:r>
-          </a:p>
-        </p:txBody>
-      </p:sp>
-      <p:sp>
-        <p:nvSpPr>
-          <p:cNvPr id="3" name="draft-5">
-            <a:extLst xmlns:a="http://schemas.openxmlformats.org/drawingml/2006/main">
-              <a:ext uri="{FF2B5EF4-FFF2-40B4-BE49-F238E27FC236}">
-                <a16:creationId xmlns:a16="http://schemas.microsoft.com/office/drawing/2014/main" id="{495C058D-643C-484F-BFE5-AE5A690268C4}"/>
-              </a:ext>
-            </a:extLst>
-          </p:cNvPr>
-          <p:cNvSpPr>
-            <a:spLocks xmlns:a="http://schemas.openxmlformats.org/drawingml/2006/main" noGrp="1"/>
-          </p:cNvSpPr>
-          <p:nvPr/>
-        </p:nvSpPr>
-        <p:spPr>
-          <a:xfrm xmlns:a="http://schemas.openxmlformats.org/drawingml/2006/main">
-            <a:off x="9191625" y="495300"/>
-            <a:ext cx="2381250" cy="266700"/>
-          </a:xfrm>
-          <a:prstGeom xmlns:a="http://schemas.openxmlformats.org/drawingml/2006/main" prst="rect">
-            <a:avLst/>
-          </a:prstGeom>
-          <a:noFill xmlns:a="http://schemas.openxmlformats.org/drawingml/2006/main"/>
-          <a:ln xmlns:a="http://schemas.openxmlformats.org/drawingml/2006/main" w="0">
-            <a:noFill/>
-            <a:prstDash val="solid"/>
-          </a:ln>
-        </p:spPr>
-        <p:txBody>
-          <a:bodyPr xmlns:a="http://schemas.openxmlformats.org/drawingml/2006/main" anchor="ctr"/>
-          <a:lstStyle xmlns:a="http://schemas.openxmlformats.org/drawingml/2006/main"/>
-          <a:p xmlns:a="http://schemas.openxmlformats.org/drawingml/2006/main">
-            <a:pPr algn="r">
-              <a:defRPr sz="1050" b="1">
-                <a:solidFill>
-                  <a:srgbClr val="B91C1C"/>
-                </a:solidFill>
-              </a:defRPr>
-            </a:pPr>
-            <a:r>
-              <a:rPr sz="1050" b="1">
-                <a:solidFill>
-                  <a:srgbClr val="B91C1C"/>
-                </a:solidFill>
-              </a:rPr>
-              <a:t>DRAFT — DATA NOT REFRESHED</a:t>
+              <a:t>Business unit performance</a:t>
             </a:r>
           </a:p>
         </p:txBody>
@@ -7275,6 +7061,7 @@
           <a:lstStyle xmlns:a="http://schemas.openxmlformats.org/drawingml/2006/main"/>
           <a:p xmlns:a="http://schemas.openxmlformats.org/drawingml/2006/main">
             <a:pPr algn="l">
+              <a:buNone/>
               <a:defRPr sz="825" b="0">
                 <a:solidFill>
                   <a:srgbClr val="5B6573"/>
@@ -7287,7 +7074,7 @@
                   <a:srgbClr val="5B6573"/>
                 </a:solidFill>
               </a:rPr>
-              <a:t>Alder Ridge Mechanical • June 2026 executive performance review • Internal working</a:t>
+              <a:t>Alder Ridge Mechanical • June 2026</a:t>
             </a:r>
           </a:p>
         </p:txBody>
@@ -7325,6 +7112,7 @@
           <a:lstStyle xmlns:a="http://schemas.openxmlformats.org/drawingml/2006/main"/>
           <a:p xmlns:a="http://schemas.openxmlformats.org/drawingml/2006/main">
             <a:pPr algn="r">
+              <a:buNone/>
               <a:defRPr sz="825" b="0">
                 <a:solidFill>
                   <a:srgbClr val="5B6573"/>
@@ -7408,6 +7196,7 @@
           <a:lstStyle xmlns:a="http://schemas.openxmlformats.org/drawingml/2006/main"/>
           <a:p xmlns:a="http://schemas.openxmlformats.org/drawingml/2006/main">
             <a:pPr algn="l">
+              <a:buNone/>
               <a:defRPr sz="1125" b="1">
                 <a:solidFill>
                   <a:srgbClr val="FFFFFF"/>
@@ -7491,6 +7280,7 @@
           <a:lstStyle xmlns:a="http://schemas.openxmlformats.org/drawingml/2006/main"/>
           <a:p xmlns:a="http://schemas.openxmlformats.org/drawingml/2006/main">
             <a:pPr algn="ctr">
+              <a:buNone/>
               <a:defRPr sz="1125" b="1">
                 <a:solidFill>
                   <a:srgbClr val="FFFFFF"/>
@@ -7503,7 +7293,7 @@
                   <a:srgbClr val="FFFFFF"/>
                 </a:solidFill>
               </a:rPr>
-              <a:t>Revenue</a:t>
+              <a:t>Revenue actual</a:t>
             </a:r>
           </a:p>
         </p:txBody>
@@ -7574,6 +7364,7 @@
           <a:lstStyle xmlns:a="http://schemas.openxmlformats.org/drawingml/2006/main"/>
           <a:p xmlns:a="http://schemas.openxmlformats.org/drawingml/2006/main">
             <a:pPr algn="ctr">
+              <a:buNone/>
               <a:defRPr sz="1125" b="1">
                 <a:solidFill>
                   <a:srgbClr val="FFFFFF"/>
@@ -7586,7 +7377,7 @@
                   <a:srgbClr val="FFFFFF"/>
                 </a:solidFill>
               </a:rPr>
-              <a:t>vs plan</a:t>
+              <a:t>Revenue plan</a:t>
             </a:r>
           </a:p>
         </p:txBody>
@@ -7657,6 +7448,7 @@
           <a:lstStyle xmlns:a="http://schemas.openxmlformats.org/drawingml/2006/main"/>
           <a:p xmlns:a="http://schemas.openxmlformats.org/drawingml/2006/main">
             <a:pPr algn="ctr">
+              <a:buNone/>
               <a:defRPr sz="1125" b="1">
                 <a:solidFill>
                   <a:srgbClr val="FFFFFF"/>
@@ -7669,7 +7461,7 @@
                   <a:srgbClr val="FFFFFF"/>
                 </a:solidFill>
               </a:rPr>
-              <a:t>Gross margin</a:t>
+              <a:t>Revenue variance</a:t>
             </a:r>
           </a:p>
         </p:txBody>
@@ -7740,6 +7532,7 @@
           <a:lstStyle xmlns:a="http://schemas.openxmlformats.org/drawingml/2006/main"/>
           <a:p xmlns:a="http://schemas.openxmlformats.org/drawingml/2006/main">
             <a:pPr algn="ctr">
+              <a:buNone/>
               <a:defRPr sz="1125" b="1">
                 <a:solidFill>
                   <a:srgbClr val="FFFFFF"/>
@@ -7752,7 +7545,7 @@
                   <a:srgbClr val="FFFFFF"/>
                 </a:solidFill>
               </a:rPr>
-              <a:t>EBITDA</a:t>
+              <a:t>EBITDA actual</a:t>
             </a:r>
           </a:p>
         </p:txBody>
@@ -7823,6 +7616,7 @@
           <a:lstStyle xmlns:a="http://schemas.openxmlformats.org/drawingml/2006/main"/>
           <a:p xmlns:a="http://schemas.openxmlformats.org/drawingml/2006/main">
             <a:pPr algn="ctr">
+              <a:buNone/>
               <a:defRPr sz="1125" b="1">
                 <a:solidFill>
                   <a:srgbClr val="FFFFFF"/>
@@ -7835,7 +7629,7 @@
                   <a:srgbClr val="FFFFFF"/>
                 </a:solidFill>
               </a:rPr>
-              <a:t>Outlook</a:t>
+              <a:t>EBITDA plan</a:t>
             </a:r>
           </a:p>
         </p:txBody>
@@ -7906,6 +7700,7 @@
           <a:lstStyle xmlns:a="http://schemas.openxmlformats.org/drawingml/2006/main"/>
           <a:p xmlns:a="http://schemas.openxmlformats.org/drawingml/2006/main">
             <a:pPr algn="ctr">
+              <a:buNone/>
               <a:defRPr sz="1125" b="1">
                 <a:solidFill>
                   <a:srgbClr val="FFFFFF"/>
@@ -7918,7 +7713,7 @@
                   <a:srgbClr val="FFFFFF"/>
                 </a:solidFill>
               </a:rPr>
-              <a:t>Owner action</a:t>
+              <a:t>EBITDA variance</a:t>
             </a:r>
           </a:p>
         </p:txBody>
@@ -7989,6 +7784,7 @@
           <a:lstStyle xmlns:a="http://schemas.openxmlformats.org/drawingml/2006/main"/>
           <a:p xmlns:a="http://schemas.openxmlformats.org/drawingml/2006/main">
             <a:pPr algn="l">
+              <a:buNone/>
               <a:defRPr sz="1275" b="1">
                 <a:solidFill>
                   <a:srgbClr val="1F2937"/>
@@ -8072,6 +7868,7 @@
           <a:lstStyle xmlns:a="http://schemas.openxmlformats.org/drawingml/2006/main"/>
           <a:p xmlns:a="http://schemas.openxmlformats.org/drawingml/2006/main">
             <a:pPr algn="ctr">
+              <a:buNone/>
               <a:defRPr sz="1425" b="0">
                 <a:solidFill>
                   <a:srgbClr val="17365D"/>
@@ -8155,6 +7952,7 @@
           <a:lstStyle xmlns:a="http://schemas.openxmlformats.org/drawingml/2006/main"/>
           <a:p xmlns:a="http://schemas.openxmlformats.org/drawingml/2006/main">
             <a:pPr algn="ctr">
+              <a:buNone/>
               <a:defRPr sz="1425" b="0">
                 <a:solidFill>
                   <a:srgbClr val="17365D"/>
@@ -8238,6 +8036,7 @@
           <a:lstStyle xmlns:a="http://schemas.openxmlformats.org/drawingml/2006/main"/>
           <a:p xmlns:a="http://schemas.openxmlformats.org/drawingml/2006/main">
             <a:pPr algn="ctr">
+              <a:buNone/>
               <a:defRPr sz="1425" b="0">
                 <a:solidFill>
                   <a:srgbClr val="17365D"/>
@@ -8321,6 +8120,7 @@
           <a:lstStyle xmlns:a="http://schemas.openxmlformats.org/drawingml/2006/main"/>
           <a:p xmlns:a="http://schemas.openxmlformats.org/drawingml/2006/main">
             <a:pPr algn="ctr">
+              <a:buNone/>
               <a:defRPr sz="1425" b="0">
                 <a:solidFill>
                   <a:srgbClr val="17365D"/>
@@ -8404,6 +8204,7 @@
           <a:lstStyle xmlns:a="http://schemas.openxmlformats.org/drawingml/2006/main"/>
           <a:p xmlns:a="http://schemas.openxmlformats.org/drawingml/2006/main">
             <a:pPr algn="ctr">
+              <a:buNone/>
               <a:defRPr sz="1425" b="0">
                 <a:solidFill>
                   <a:srgbClr val="17365D"/>
@@ -8487,6 +8288,7 @@
           <a:lstStyle xmlns:a="http://schemas.openxmlformats.org/drawingml/2006/main"/>
           <a:p xmlns:a="http://schemas.openxmlformats.org/drawingml/2006/main">
             <a:pPr algn="ctr">
+              <a:buNone/>
               <a:defRPr sz="1425" b="0">
                 <a:solidFill>
                   <a:srgbClr val="17365D"/>
@@ -8570,6 +8372,7 @@
           <a:lstStyle xmlns:a="http://schemas.openxmlformats.org/drawingml/2006/main"/>
           <a:p xmlns:a="http://schemas.openxmlformats.org/drawingml/2006/main">
             <a:pPr algn="l">
+              <a:buNone/>
               <a:defRPr sz="1275" b="1">
                 <a:solidFill>
                   <a:srgbClr val="1F2937"/>
@@ -8653,6 +8456,7 @@
           <a:lstStyle xmlns:a="http://schemas.openxmlformats.org/drawingml/2006/main"/>
           <a:p xmlns:a="http://schemas.openxmlformats.org/drawingml/2006/main">
             <a:pPr algn="ctr">
+              <a:buNone/>
               <a:defRPr sz="1425" b="0">
                 <a:solidFill>
                   <a:srgbClr val="17365D"/>
@@ -8736,6 +8540,7 @@
           <a:lstStyle xmlns:a="http://schemas.openxmlformats.org/drawingml/2006/main"/>
           <a:p xmlns:a="http://schemas.openxmlformats.org/drawingml/2006/main">
             <a:pPr algn="ctr">
+              <a:buNone/>
               <a:defRPr sz="1425" b="0">
                 <a:solidFill>
                   <a:srgbClr val="17365D"/>
@@ -8819,6 +8624,7 @@
           <a:lstStyle xmlns:a="http://schemas.openxmlformats.org/drawingml/2006/main"/>
           <a:p xmlns:a="http://schemas.openxmlformats.org/drawingml/2006/main">
             <a:pPr algn="ctr">
+              <a:buNone/>
               <a:defRPr sz="1425" b="0">
                 <a:solidFill>
                   <a:srgbClr val="17365D"/>
@@ -8902,6 +8708,7 @@
           <a:lstStyle xmlns:a="http://schemas.openxmlformats.org/drawingml/2006/main"/>
           <a:p xmlns:a="http://schemas.openxmlformats.org/drawingml/2006/main">
             <a:pPr algn="ctr">
+              <a:buNone/>
               <a:defRPr sz="1425" b="0">
                 <a:solidFill>
                   <a:srgbClr val="17365D"/>
@@ -8985,6 +8792,7 @@
           <a:lstStyle xmlns:a="http://schemas.openxmlformats.org/drawingml/2006/main"/>
           <a:p xmlns:a="http://schemas.openxmlformats.org/drawingml/2006/main">
             <a:pPr algn="ctr">
+              <a:buNone/>
               <a:defRPr sz="1425" b="0">
                 <a:solidFill>
                   <a:srgbClr val="17365D"/>
@@ -9068,6 +8876,7 @@
           <a:lstStyle xmlns:a="http://schemas.openxmlformats.org/drawingml/2006/main"/>
           <a:p xmlns:a="http://schemas.openxmlformats.org/drawingml/2006/main">
             <a:pPr algn="ctr">
+              <a:buNone/>
               <a:defRPr sz="1425" b="0">
                 <a:solidFill>
                   <a:srgbClr val="17365D"/>
@@ -9151,6 +8960,7 @@
           <a:lstStyle xmlns:a="http://schemas.openxmlformats.org/drawingml/2006/main"/>
           <a:p xmlns:a="http://schemas.openxmlformats.org/drawingml/2006/main">
             <a:pPr algn="l">
+              <a:buNone/>
               <a:defRPr sz="1275" b="1">
                 <a:solidFill>
                   <a:srgbClr val="1F2937"/>
@@ -9234,6 +9044,7 @@
           <a:lstStyle xmlns:a="http://schemas.openxmlformats.org/drawingml/2006/main"/>
           <a:p xmlns:a="http://schemas.openxmlformats.org/drawingml/2006/main">
             <a:pPr algn="ctr">
+              <a:buNone/>
               <a:defRPr sz="1425" b="0">
                 <a:solidFill>
                   <a:srgbClr val="17365D"/>
@@ -9317,6 +9128,7 @@
           <a:lstStyle xmlns:a="http://schemas.openxmlformats.org/drawingml/2006/main"/>
           <a:p xmlns:a="http://schemas.openxmlformats.org/drawingml/2006/main">
             <a:pPr algn="ctr">
+              <a:buNone/>
               <a:defRPr sz="1425" b="0">
                 <a:solidFill>
                   <a:srgbClr val="17365D"/>
@@ -9400,6 +9212,7 @@
           <a:lstStyle xmlns:a="http://schemas.openxmlformats.org/drawingml/2006/main"/>
           <a:p xmlns:a="http://schemas.openxmlformats.org/drawingml/2006/main">
             <a:pPr algn="ctr">
+              <a:buNone/>
               <a:defRPr sz="1425" b="0">
                 <a:solidFill>
                   <a:srgbClr val="17365D"/>
@@ -9483,6 +9296,7 @@
           <a:lstStyle xmlns:a="http://schemas.openxmlformats.org/drawingml/2006/main"/>
           <a:p xmlns:a="http://schemas.openxmlformats.org/drawingml/2006/main">
             <a:pPr algn="ctr">
+              <a:buNone/>
               <a:defRPr sz="1425" b="0">
                 <a:solidFill>
                   <a:srgbClr val="17365D"/>
@@ -9566,6 +9380,7 @@
           <a:lstStyle xmlns:a="http://schemas.openxmlformats.org/drawingml/2006/main"/>
           <a:p xmlns:a="http://schemas.openxmlformats.org/drawingml/2006/main">
             <a:pPr algn="ctr">
+              <a:buNone/>
               <a:defRPr sz="1425" b="0">
                 <a:solidFill>
                   <a:srgbClr val="17365D"/>
@@ -9649,6 +9464,7 @@
           <a:lstStyle xmlns:a="http://schemas.openxmlformats.org/drawingml/2006/main"/>
           <a:p xmlns:a="http://schemas.openxmlformats.org/drawingml/2006/main">
             <a:pPr algn="ctr">
+              <a:buNone/>
               <a:defRPr sz="1425" b="0">
                 <a:solidFill>
                   <a:srgbClr val="17365D"/>
@@ -9732,6 +9548,7 @@
           <a:lstStyle xmlns:a="http://schemas.openxmlformats.org/drawingml/2006/main"/>
           <a:p xmlns:a="http://schemas.openxmlformats.org/drawingml/2006/main">
             <a:pPr algn="l">
+              <a:buNone/>
               <a:defRPr sz="1275" b="1">
                 <a:solidFill>
                   <a:srgbClr val="1F2937"/>
@@ -9815,6 +9632,7 @@
           <a:lstStyle xmlns:a="http://schemas.openxmlformats.org/drawingml/2006/main"/>
           <a:p xmlns:a="http://schemas.openxmlformats.org/drawingml/2006/main">
             <a:pPr algn="ctr">
+              <a:buNone/>
               <a:defRPr sz="1425" b="0">
                 <a:solidFill>
                   <a:srgbClr val="17365D"/>
@@ -9898,6 +9716,7 @@
           <a:lstStyle xmlns:a="http://schemas.openxmlformats.org/drawingml/2006/main"/>
           <a:p xmlns:a="http://schemas.openxmlformats.org/drawingml/2006/main">
             <a:pPr algn="ctr">
+              <a:buNone/>
               <a:defRPr sz="1425" b="0">
                 <a:solidFill>
                   <a:srgbClr val="17365D"/>
@@ -9981,6 +9800,7 @@
           <a:lstStyle xmlns:a="http://schemas.openxmlformats.org/drawingml/2006/main"/>
           <a:p xmlns:a="http://schemas.openxmlformats.org/drawingml/2006/main">
             <a:pPr algn="ctr">
+              <a:buNone/>
               <a:defRPr sz="1425" b="0">
                 <a:solidFill>
                   <a:srgbClr val="17365D"/>
@@ -10064,6 +9884,7 @@
           <a:lstStyle xmlns:a="http://schemas.openxmlformats.org/drawingml/2006/main"/>
           <a:p xmlns:a="http://schemas.openxmlformats.org/drawingml/2006/main">
             <a:pPr algn="ctr">
+              <a:buNone/>
               <a:defRPr sz="1425" b="0">
                 <a:solidFill>
                   <a:srgbClr val="17365D"/>
@@ -10147,6 +9968,7 @@
           <a:lstStyle xmlns:a="http://schemas.openxmlformats.org/drawingml/2006/main"/>
           <a:p xmlns:a="http://schemas.openxmlformats.org/drawingml/2006/main">
             <a:pPr algn="ctr">
+              <a:buNone/>
               <a:defRPr sz="1425" b="0">
                 <a:solidFill>
                   <a:srgbClr val="17365D"/>
@@ -10230,6 +10052,7 @@
           <a:lstStyle xmlns:a="http://schemas.openxmlformats.org/drawingml/2006/main"/>
           <a:p xmlns:a="http://schemas.openxmlformats.org/drawingml/2006/main">
             <a:pPr algn="ctr">
+              <a:buNone/>
               <a:defRPr sz="1425" b="0">
                 <a:solidFill>
                   <a:srgbClr val="17365D"/>
@@ -10313,6 +10136,7 @@
           <a:lstStyle xmlns:a="http://schemas.openxmlformats.org/drawingml/2006/main"/>
           <a:p xmlns:a="http://schemas.openxmlformats.org/drawingml/2006/main">
             <a:pPr algn="l">
+              <a:buNone/>
               <a:defRPr sz="1275" b="1">
                 <a:solidFill>
                   <a:srgbClr val="1F2937"/>
@@ -10396,6 +10220,7 @@
           <a:lstStyle xmlns:a="http://schemas.openxmlformats.org/drawingml/2006/main"/>
           <a:p xmlns:a="http://schemas.openxmlformats.org/drawingml/2006/main">
             <a:pPr algn="ctr">
+              <a:buNone/>
               <a:defRPr sz="1425" b="1">
                 <a:solidFill>
                   <a:srgbClr val="17365D"/>
@@ -10479,6 +10304,7 @@
           <a:lstStyle xmlns:a="http://schemas.openxmlformats.org/drawingml/2006/main"/>
           <a:p xmlns:a="http://schemas.openxmlformats.org/drawingml/2006/main">
             <a:pPr algn="ctr">
+              <a:buNone/>
               <a:defRPr sz="1425" b="1">
                 <a:solidFill>
                   <a:srgbClr val="17365D"/>
@@ -10562,6 +10388,7 @@
           <a:lstStyle xmlns:a="http://schemas.openxmlformats.org/drawingml/2006/main"/>
           <a:p xmlns:a="http://schemas.openxmlformats.org/drawingml/2006/main">
             <a:pPr algn="ctr">
+              <a:buNone/>
               <a:defRPr sz="1425" b="1">
                 <a:solidFill>
                   <a:srgbClr val="17365D"/>
@@ -10645,6 +10472,7 @@
           <a:lstStyle xmlns:a="http://schemas.openxmlformats.org/drawingml/2006/main"/>
           <a:p xmlns:a="http://schemas.openxmlformats.org/drawingml/2006/main">
             <a:pPr algn="ctr">
+              <a:buNone/>
               <a:defRPr sz="1425" b="1">
                 <a:solidFill>
                   <a:srgbClr val="17365D"/>
@@ -10728,6 +10556,7 @@
           <a:lstStyle xmlns:a="http://schemas.openxmlformats.org/drawingml/2006/main"/>
           <a:p xmlns:a="http://schemas.openxmlformats.org/drawingml/2006/main">
             <a:pPr algn="ctr">
+              <a:buNone/>
               <a:defRPr sz="1425" b="1">
                 <a:solidFill>
                   <a:srgbClr val="17365D"/>
@@ -10811,6 +10640,7 @@
           <a:lstStyle xmlns:a="http://schemas.openxmlformats.org/drawingml/2006/main"/>
           <a:p xmlns:a="http://schemas.openxmlformats.org/drawingml/2006/main">
             <a:pPr algn="ctr">
+              <a:buNone/>
               <a:defRPr sz="1425" b="1">
                 <a:solidFill>
                   <a:srgbClr val="17365D"/>
@@ -10859,7 +10689,7 @@
       </p:grpSpPr>
       <p:sp>
         <p:nvSpPr>
-          <p:cNvPr id="1" name="header-6">
+          <p:cNvPr id="47" name="header-6">
             <a:extLst xmlns:a="http://schemas.openxmlformats.org/drawingml/2006/main">
               <a:ext uri="{FF2B5EF4-FFF2-40B4-BE49-F238E27FC236}">
                 <a16:creationId xmlns:a16="http://schemas.microsoft.com/office/drawing/2014/main" id="{CD51639A-39AB-432F-B1C8-562700D4DB58}"/>
@@ -10921,6 +10751,7 @@
           <a:lstStyle xmlns:a="http://schemas.openxmlformats.org/drawingml/2006/main"/>
           <a:p xmlns:a="http://schemas.openxmlformats.org/drawingml/2006/main">
             <a:pPr algn="l">
+              <a:buNone/>
               <a:defRPr sz="2625" b="1">
                 <a:solidFill>
                   <a:srgbClr val="17365D"/>
@@ -10933,57 +10764,7 @@
                   <a:srgbClr val="17365D"/>
                 </a:solidFill>
               </a:rPr>
-              <a:t>Cash conversion: separate operating performance from timing</a:t>
-            </a:r>
-          </a:p>
-        </p:txBody>
-      </p:sp>
-      <p:sp>
-        <p:nvSpPr>
-          <p:cNvPr id="3" name="draft-6">
-            <a:extLst xmlns:a="http://schemas.openxmlformats.org/drawingml/2006/main">
-              <a:ext uri="{FF2B5EF4-FFF2-40B4-BE49-F238E27FC236}">
-                <a16:creationId xmlns:a16="http://schemas.microsoft.com/office/drawing/2014/main" id="{2AC786B3-5E69-4C8D-8AC6-D7177C3DDB80}"/>
-              </a:ext>
-            </a:extLst>
-          </p:cNvPr>
-          <p:cNvSpPr>
-            <a:spLocks xmlns:a="http://schemas.openxmlformats.org/drawingml/2006/main" noGrp="1"/>
-          </p:cNvSpPr>
-          <p:nvPr/>
-        </p:nvSpPr>
-        <p:spPr>
-          <a:xfrm xmlns:a="http://schemas.openxmlformats.org/drawingml/2006/main">
-            <a:off x="9191625" y="495300"/>
-            <a:ext cx="2381250" cy="266700"/>
-          </a:xfrm>
-          <a:prstGeom xmlns:a="http://schemas.openxmlformats.org/drawingml/2006/main" prst="rect">
-            <a:avLst/>
-          </a:prstGeom>
-          <a:noFill xmlns:a="http://schemas.openxmlformats.org/drawingml/2006/main"/>
-          <a:ln xmlns:a="http://schemas.openxmlformats.org/drawingml/2006/main" w="0">
-            <a:noFill/>
-            <a:prstDash val="solid"/>
-          </a:ln>
-        </p:spPr>
-        <p:txBody>
-          <a:bodyPr xmlns:a="http://schemas.openxmlformats.org/drawingml/2006/main" anchor="ctr"/>
-          <a:lstStyle xmlns:a="http://schemas.openxmlformats.org/drawingml/2006/main"/>
-          <a:p xmlns:a="http://schemas.openxmlformats.org/drawingml/2006/main">
-            <a:pPr algn="r">
-              <a:defRPr sz="1050" b="1">
-                <a:solidFill>
-                  <a:srgbClr val="B91C1C"/>
-                </a:solidFill>
-              </a:defRPr>
-            </a:pPr>
-            <a:r>
-              <a:rPr sz="1050" b="1">
-                <a:solidFill>
-                  <a:srgbClr val="B91C1C"/>
-                </a:solidFill>
-              </a:rPr>
-              <a:t>DRAFT — DATA NOT REFRESHED</a:t>
+              <a:t>Cash flow and liquidity</a:t>
             </a:r>
           </a:p>
         </p:txBody>
@@ -11052,6 +10833,7 @@
           <a:lstStyle xmlns:a="http://schemas.openxmlformats.org/drawingml/2006/main"/>
           <a:p xmlns:a="http://schemas.openxmlformats.org/drawingml/2006/main">
             <a:pPr algn="l">
+              <a:buNone/>
               <a:defRPr sz="825" b="0">
                 <a:solidFill>
                   <a:srgbClr val="5B6573"/>
@@ -11064,7 +10846,7 @@
                   <a:srgbClr val="5B6573"/>
                 </a:solidFill>
               </a:rPr>
-              <a:t>Alder Ridge Mechanical • June 2026 executive performance review • Internal working</a:t>
+              <a:t>Alder Ridge Mechanical • June 2026</a:t>
             </a:r>
           </a:p>
         </p:txBody>
@@ -11102,6 +10884,7 @@
           <a:lstStyle xmlns:a="http://schemas.openxmlformats.org/drawingml/2006/main"/>
           <a:p xmlns:a="http://schemas.openxmlformats.org/drawingml/2006/main">
             <a:pPr algn="r">
+              <a:buNone/>
               <a:defRPr sz="825" b="0">
                 <a:solidFill>
                   <a:srgbClr val="5B6573"/>
@@ -11185,6 +10968,7 @@
           <a:lstStyle xmlns:a="http://schemas.openxmlformats.org/drawingml/2006/main"/>
           <a:p xmlns:a="http://schemas.openxmlformats.org/drawingml/2006/main">
             <a:pPr algn="l">
+              <a:buNone/>
               <a:defRPr sz="1050" b="1">
                 <a:solidFill>
                   <a:srgbClr val="5B6573"/>
@@ -11235,6 +11019,7 @@
           <a:lstStyle xmlns:a="http://schemas.openxmlformats.org/drawingml/2006/main"/>
           <a:p xmlns:a="http://schemas.openxmlformats.org/drawingml/2006/main">
             <a:pPr algn="l">
+              <a:buNone/>
               <a:defRPr sz="2025" b="1">
                 <a:solidFill>
                   <a:srgbClr val="17365D"/>
@@ -11318,6 +11103,7 @@
           <a:lstStyle xmlns:a="http://schemas.openxmlformats.org/drawingml/2006/main"/>
           <a:p xmlns:a="http://schemas.openxmlformats.org/drawingml/2006/main">
             <a:pPr algn="l">
+              <a:buNone/>
               <a:defRPr sz="1050" b="1">
                 <a:solidFill>
                   <a:srgbClr val="5B6573"/>
@@ -11330,7 +11116,7 @@
                   <a:srgbClr val="5B6573"/>
                 </a:solidFill>
               </a:rPr>
-              <a:t>Ending available cash</a:t>
+              <a:t>Unrestricted cash</a:t>
             </a:r>
           </a:p>
         </p:txBody>
@@ -11368,6 +11154,7 @@
           <a:lstStyle xmlns:a="http://schemas.openxmlformats.org/drawingml/2006/main"/>
           <a:p xmlns:a="http://schemas.openxmlformats.org/drawingml/2006/main">
             <a:pPr algn="l">
+              <a:buNone/>
               <a:defRPr sz="2025" b="1">
                 <a:solidFill>
                   <a:srgbClr val="17365D"/>
@@ -11451,6 +11238,7 @@
           <a:lstStyle xmlns:a="http://schemas.openxmlformats.org/drawingml/2006/main"/>
           <a:p xmlns:a="http://schemas.openxmlformats.org/drawingml/2006/main">
             <a:pPr algn="l">
+              <a:buNone/>
               <a:defRPr sz="1050" b="1">
                 <a:solidFill>
                   <a:srgbClr val="5B6573"/>
@@ -11501,6 +11289,7 @@
           <a:lstStyle xmlns:a="http://schemas.openxmlformats.org/drawingml/2006/main"/>
           <a:p xmlns:a="http://schemas.openxmlformats.org/drawingml/2006/main">
             <a:pPr algn="l">
+              <a:buNone/>
               <a:defRPr sz="2025" b="1">
                 <a:solidFill>
                   <a:srgbClr val="17365D"/>
@@ -11584,6 +11373,7 @@
           <a:lstStyle xmlns:a="http://schemas.openxmlformats.org/drawingml/2006/main"/>
           <a:p xmlns:a="http://schemas.openxmlformats.org/drawingml/2006/main">
             <a:pPr algn="l">
+              <a:buNone/>
               <a:defRPr sz="1050" b="1">
                 <a:solidFill>
                   <a:srgbClr val="5B6573"/>
@@ -11596,7 +11386,7 @@
                   <a:srgbClr val="5B6573"/>
                 </a:solidFill>
               </a:rPr>
-              <a:t>Cash conversion</a:t>
+              <a:t>Free cash flow vs plan</a:t>
             </a:r>
           </a:p>
         </p:txBody>
@@ -11634,6 +11424,7 @@
           <a:lstStyle xmlns:a="http://schemas.openxmlformats.org/drawingml/2006/main"/>
           <a:p xmlns:a="http://schemas.openxmlformats.org/drawingml/2006/main">
             <a:pPr algn="l">
+              <a:buNone/>
               <a:defRPr sz="2025" b="1">
                 <a:solidFill>
                   <a:srgbClr val="17365D"/>
@@ -11684,6 +11475,7 @@
           <a:lstStyle xmlns:a="http://schemas.openxmlformats.org/drawingml/2006/main"/>
           <a:p xmlns:a="http://schemas.openxmlformats.org/drawingml/2006/main">
             <a:pPr algn="l">
+              <a:buNone/>
               <a:defRPr sz="1650" b="1">
                 <a:solidFill>
                   <a:srgbClr val="17365D"/>
@@ -11696,7 +11488,7 @@
                   <a:srgbClr val="17365D"/>
                 </a:solidFill>
               </a:rPr>
-              <a:t>Working-capital movements ($ millions)</a:t>
+              <a:t>Cash flow bridge ($ millions)</a:t>
             </a:r>
           </a:p>
         </p:txBody>
@@ -11767,6 +11559,7 @@
           <a:lstStyle xmlns:a="http://schemas.openxmlformats.org/drawingml/2006/main"/>
           <a:p xmlns:a="http://schemas.openxmlformats.org/drawingml/2006/main">
             <a:pPr algn="l">
+              <a:buNone/>
               <a:defRPr sz="1200" b="0">
                 <a:solidFill>
                   <a:srgbClr val="1F2937"/>
@@ -11779,7 +11572,7 @@
                   <a:srgbClr val="1F2937"/>
                 </a:solidFill>
               </a:rPr>
-              <a:t>Accounts receivable</a:t>
+              <a:t>Operating cash flow</a:t>
             </a:r>
           </a:p>
         </p:txBody>
@@ -11817,6 +11610,7 @@
           <a:lstStyle xmlns:a="http://schemas.openxmlformats.org/drawingml/2006/main"/>
           <a:p xmlns:a="http://schemas.openxmlformats.org/drawingml/2006/main">
             <a:pPr algn="r">
+              <a:buNone/>
               <a:defRPr sz="1200" b="1">
                 <a:solidFill>
                   <a:srgbClr val="17365D"/>
@@ -11867,6 +11661,7 @@
           <a:lstStyle xmlns:a="http://schemas.openxmlformats.org/drawingml/2006/main"/>
           <a:p xmlns:a="http://schemas.openxmlformats.org/drawingml/2006/main">
             <a:pPr algn="r">
+              <a:buNone/>
               <a:defRPr sz="1200" b="0">
                 <a:solidFill>
                   <a:srgbClr val="5B6573"/>
@@ -11950,6 +11745,7 @@
           <a:lstStyle xmlns:a="http://schemas.openxmlformats.org/drawingml/2006/main"/>
           <a:p xmlns:a="http://schemas.openxmlformats.org/drawingml/2006/main">
             <a:pPr algn="l">
+              <a:buNone/>
               <a:defRPr sz="1200" b="0">
                 <a:solidFill>
                   <a:srgbClr val="1F2937"/>
@@ -11962,7 +11758,7 @@
                   <a:srgbClr val="1F2937"/>
                 </a:solidFill>
               </a:rPr>
-              <a:t>Retainage</a:t>
+              <a:t>Capital expenditure</a:t>
             </a:r>
           </a:p>
         </p:txBody>
@@ -12000,6 +11796,7 @@
           <a:lstStyle xmlns:a="http://schemas.openxmlformats.org/drawingml/2006/main"/>
           <a:p xmlns:a="http://schemas.openxmlformats.org/drawingml/2006/main">
             <a:pPr algn="r">
+              <a:buNone/>
               <a:defRPr sz="1200" b="1">
                 <a:solidFill>
                   <a:srgbClr val="17365D"/>
@@ -12050,6 +11847,7 @@
           <a:lstStyle xmlns:a="http://schemas.openxmlformats.org/drawingml/2006/main"/>
           <a:p xmlns:a="http://schemas.openxmlformats.org/drawingml/2006/main">
             <a:pPr algn="r">
+              <a:buNone/>
               <a:defRPr sz="1200" b="0">
                 <a:solidFill>
                   <a:srgbClr val="5B6573"/>
@@ -12133,6 +11931,7 @@
           <a:lstStyle xmlns:a="http://schemas.openxmlformats.org/drawingml/2006/main"/>
           <a:p xmlns:a="http://schemas.openxmlformats.org/drawingml/2006/main">
             <a:pPr algn="l">
+              <a:buNone/>
               <a:defRPr sz="1200" b="0">
                 <a:solidFill>
                   <a:srgbClr val="1F2937"/>
@@ -12145,7 +11944,7 @@
                   <a:srgbClr val="1F2937"/>
                 </a:solidFill>
               </a:rPr>
-              <a:t>Inventory</a:t>
+              <a:t>Free cash flow</a:t>
             </a:r>
           </a:p>
         </p:txBody>
@@ -12183,6 +11982,7 @@
           <a:lstStyle xmlns:a="http://schemas.openxmlformats.org/drawingml/2006/main"/>
           <a:p xmlns:a="http://schemas.openxmlformats.org/drawingml/2006/main">
             <a:pPr algn="r">
+              <a:buNone/>
               <a:defRPr sz="1200" b="1">
                 <a:solidFill>
                   <a:srgbClr val="17365D"/>
@@ -12233,6 +12033,7 @@
           <a:lstStyle xmlns:a="http://schemas.openxmlformats.org/drawingml/2006/main"/>
           <a:p xmlns:a="http://schemas.openxmlformats.org/drawingml/2006/main">
             <a:pPr algn="r">
+              <a:buNone/>
               <a:defRPr sz="1200" b="0">
                 <a:solidFill>
                   <a:srgbClr val="5B6573"/>
@@ -12316,6 +12117,7 @@
           <a:lstStyle xmlns:a="http://schemas.openxmlformats.org/drawingml/2006/main"/>
           <a:p xmlns:a="http://schemas.openxmlformats.org/drawingml/2006/main">
             <a:pPr algn="l">
+              <a:buNone/>
               <a:defRPr sz="1200" b="0">
                 <a:solidFill>
                   <a:srgbClr val="1F2937"/>
@@ -12328,7 +12130,7 @@
                   <a:srgbClr val="1F2937"/>
                 </a:solidFill>
               </a:rPr>
-              <a:t>Accounts payable</a:t>
+              <a:t>Free cash flow plan</a:t>
             </a:r>
           </a:p>
         </p:txBody>
@@ -12366,6 +12168,7 @@
           <a:lstStyle xmlns:a="http://schemas.openxmlformats.org/drawingml/2006/main"/>
           <a:p xmlns:a="http://schemas.openxmlformats.org/drawingml/2006/main">
             <a:pPr algn="r">
+              <a:buNone/>
               <a:defRPr sz="1200" b="1">
                 <a:solidFill>
                   <a:srgbClr val="17365D"/>
@@ -12416,6 +12219,7 @@
           <a:lstStyle xmlns:a="http://schemas.openxmlformats.org/drawingml/2006/main"/>
           <a:p xmlns:a="http://schemas.openxmlformats.org/drawingml/2006/main">
             <a:pPr algn="r">
+              <a:buNone/>
               <a:defRPr sz="1200" b="0">
                 <a:solidFill>
                   <a:srgbClr val="5B6573"/>
@@ -12499,6 +12303,7 @@
           <a:lstStyle xmlns:a="http://schemas.openxmlformats.org/drawingml/2006/main"/>
           <a:p xmlns:a="http://schemas.openxmlformats.org/drawingml/2006/main">
             <a:pPr algn="l">
+              <a:buNone/>
               <a:defRPr sz="1200" b="0">
                 <a:solidFill>
                   <a:srgbClr val="1F2937"/>
@@ -12511,7 +12316,7 @@
                   <a:srgbClr val="1F2937"/>
                 </a:solidFill>
               </a:rPr>
-              <a:t>Customer deposits</a:t>
+              <a:t>Variance to plan</a:t>
             </a:r>
           </a:p>
         </p:txBody>
@@ -12549,6 +12354,7 @@
           <a:lstStyle xmlns:a="http://schemas.openxmlformats.org/drawingml/2006/main"/>
           <a:p xmlns:a="http://schemas.openxmlformats.org/drawingml/2006/main">
             <a:pPr algn="r">
+              <a:buNone/>
               <a:defRPr sz="1200" b="1">
                 <a:solidFill>
                   <a:srgbClr val="17365D"/>
@@ -12599,6 +12405,7 @@
           <a:lstStyle xmlns:a="http://schemas.openxmlformats.org/drawingml/2006/main"/>
           <a:p xmlns:a="http://schemas.openxmlformats.org/drawingml/2006/main">
             <a:pPr algn="r">
+              <a:buNone/>
               <a:defRPr sz="1200" b="0">
                 <a:solidFill>
                   <a:srgbClr val="5B6573"/>
@@ -12682,6 +12489,7 @@
           <a:lstStyle xmlns:a="http://schemas.openxmlformats.org/drawingml/2006/main"/>
           <a:p xmlns:a="http://schemas.openxmlformats.org/drawingml/2006/main">
             <a:pPr algn="l">
+              <a:buNone/>
               <a:defRPr sz="1200" b="1">
                 <a:solidFill>
                   <a:srgbClr val="1F2937"/>
@@ -12694,7 +12502,7 @@
                   <a:srgbClr val="1F2937"/>
                 </a:solidFill>
               </a:rPr>
-              <a:t>Net working capital</a:t>
+              <a:t>Collections timing</a:t>
             </a:r>
           </a:p>
         </p:txBody>
@@ -12732,6 +12540,7 @@
           <a:lstStyle xmlns:a="http://schemas.openxmlformats.org/drawingml/2006/main"/>
           <a:p xmlns:a="http://schemas.openxmlformats.org/drawingml/2006/main">
             <a:pPr algn="r">
+              <a:buNone/>
               <a:defRPr sz="1200" b="1">
                 <a:solidFill>
                   <a:srgbClr val="17365D"/>
@@ -12782,6 +12591,7 @@
           <a:lstStyle xmlns:a="http://schemas.openxmlformats.org/drawingml/2006/main"/>
           <a:p xmlns:a="http://schemas.openxmlformats.org/drawingml/2006/main">
             <a:pPr algn="r">
+              <a:buNone/>
               <a:defRPr sz="1200" b="0">
                 <a:solidFill>
                   <a:srgbClr val="5B6573"/>
@@ -12865,6 +12675,7 @@
           <a:lstStyle xmlns:a="http://schemas.openxmlformats.org/drawingml/2006/main"/>
           <a:p xmlns:a="http://schemas.openxmlformats.org/drawingml/2006/main">
             <a:pPr algn="l">
+              <a:buNone/>
               <a:defRPr sz="1500" b="1">
                 <a:solidFill>
                   <a:srgbClr val="17365D"/>
@@ -12877,7 +12688,7 @@
                   <a:srgbClr val="17365D"/>
                 </a:solidFill>
               </a:rPr>
-              <a:t>Management focus</a:t>
+              <a:t>Commentary</a:t>
             </a:r>
           </a:p>
         </p:txBody>
@@ -12915,6 +12726,7 @@
           <a:lstStyle xmlns:a="http://schemas.openxmlformats.org/drawingml/2006/main"/>
           <a:p xmlns:a="http://schemas.openxmlformats.org/drawingml/2006/main">
             <a:pPr algn="l">
+              <a:buNone/>
               <a:defRPr sz="1350" b="0">
                 <a:solidFill>
                   <a:srgbClr val="1F2937"/>
@@ -12927,7 +12739,7 @@
                   <a:srgbClr val="1F2937"/>
                 </a:solidFill>
               </a:rPr>
-              <a:t>Quantify the timing issue, owner, next decision date, and effect on minimum liquidity.</a:t>
+              <a:t>—</a:t>
             </a:r>
           </a:p>
         </p:txBody>
@@ -12963,7 +12775,7 @@
       </p:grpSpPr>
       <p:sp>
         <p:nvSpPr>
-          <p:cNvPr id="1" name="header-7">
+          <p:cNvPr id="34" name="header-7">
             <a:extLst xmlns:a="http://schemas.openxmlformats.org/drawingml/2006/main">
               <a:ext uri="{FF2B5EF4-FFF2-40B4-BE49-F238E27FC236}">
                 <a16:creationId xmlns:a16="http://schemas.microsoft.com/office/drawing/2014/main" id="{5FF2D5B5-1C79-4720-B98E-182CB4D5F0A9}"/>
@@ -13025,6 +12837,7 @@
           <a:lstStyle xmlns:a="http://schemas.openxmlformats.org/drawingml/2006/main"/>
           <a:p xmlns:a="http://schemas.openxmlformats.org/drawingml/2006/main">
             <a:pPr algn="l">
+              <a:buNone/>
               <a:defRPr sz="2625" b="1">
                 <a:solidFill>
                   <a:srgbClr val="17365D"/>
@@ -13037,57 +12850,7 @@
                   <a:srgbClr val="17365D"/>
                 </a:solidFill>
               </a:rPr>
-              <a:t>Backlog and outlook: show where coverage becomes capacity risk</a:t>
-            </a:r>
-          </a:p>
-        </p:txBody>
-      </p:sp>
-      <p:sp>
-        <p:nvSpPr>
-          <p:cNvPr id="3" name="draft-7">
-            <a:extLst xmlns:a="http://schemas.openxmlformats.org/drawingml/2006/main">
-              <a:ext uri="{FF2B5EF4-FFF2-40B4-BE49-F238E27FC236}">
-                <a16:creationId xmlns:a16="http://schemas.microsoft.com/office/drawing/2014/main" id="{90DDBBEE-8D37-4E41-91A0-D72CC233618C}"/>
-              </a:ext>
-            </a:extLst>
-          </p:cNvPr>
-          <p:cNvSpPr>
-            <a:spLocks xmlns:a="http://schemas.openxmlformats.org/drawingml/2006/main" noGrp="1"/>
-          </p:cNvSpPr>
-          <p:nvPr/>
-        </p:nvSpPr>
-        <p:spPr>
-          <a:xfrm xmlns:a="http://schemas.openxmlformats.org/drawingml/2006/main">
-            <a:off x="9191625" y="495300"/>
-            <a:ext cx="2381250" cy="266700"/>
-          </a:xfrm>
-          <a:prstGeom xmlns:a="http://schemas.openxmlformats.org/drawingml/2006/main" prst="rect">
-            <a:avLst/>
-          </a:prstGeom>
-          <a:noFill xmlns:a="http://schemas.openxmlformats.org/drawingml/2006/main"/>
-          <a:ln xmlns:a="http://schemas.openxmlformats.org/drawingml/2006/main" w="0">
-            <a:noFill/>
-            <a:prstDash val="solid"/>
-          </a:ln>
-        </p:spPr>
-        <p:txBody>
-          <a:bodyPr xmlns:a="http://schemas.openxmlformats.org/drawingml/2006/main" anchor="ctr"/>
-          <a:lstStyle xmlns:a="http://schemas.openxmlformats.org/drawingml/2006/main"/>
-          <a:p xmlns:a="http://schemas.openxmlformats.org/drawingml/2006/main">
-            <a:pPr algn="r">
-              <a:defRPr sz="1050" b="1">
-                <a:solidFill>
-                  <a:srgbClr val="B91C1C"/>
-                </a:solidFill>
-              </a:defRPr>
-            </a:pPr>
-            <a:r>
-              <a:rPr sz="1050" b="1">
-                <a:solidFill>
-                  <a:srgbClr val="B91C1C"/>
-                </a:solidFill>
-              </a:rPr>
-              <a:t>DRAFT — DATA NOT REFRESHED</a:t>
+              <a:t>Backlog and outlook</a:t>
             </a:r>
           </a:p>
         </p:txBody>
@@ -13156,6 +12919,7 @@
           <a:lstStyle xmlns:a="http://schemas.openxmlformats.org/drawingml/2006/main"/>
           <a:p xmlns:a="http://schemas.openxmlformats.org/drawingml/2006/main">
             <a:pPr algn="l">
+              <a:buNone/>
               <a:defRPr sz="825" b="0">
                 <a:solidFill>
                   <a:srgbClr val="5B6573"/>
@@ -13168,7 +12932,7 @@
                   <a:srgbClr val="5B6573"/>
                 </a:solidFill>
               </a:rPr>
-              <a:t>Alder Ridge Mechanical • June 2026 executive performance review • Internal working</a:t>
+              <a:t>Alder Ridge Mechanical • June 2026</a:t>
             </a:r>
           </a:p>
         </p:txBody>
@@ -13206,6 +12970,7 @@
           <a:lstStyle xmlns:a="http://schemas.openxmlformats.org/drawingml/2006/main"/>
           <a:p xmlns:a="http://schemas.openxmlformats.org/drawingml/2006/main">
             <a:pPr algn="r">
+              <a:buNone/>
               <a:defRPr sz="825" b="0">
                 <a:solidFill>
                   <a:srgbClr val="5B6573"/>
@@ -13289,6 +13054,7 @@
           <a:lstStyle xmlns:a="http://schemas.openxmlformats.org/drawingml/2006/main"/>
           <a:p xmlns:a="http://schemas.openxmlformats.org/drawingml/2006/main">
             <a:pPr algn="l">
+              <a:buNone/>
               <a:defRPr sz="1050" b="1">
                 <a:solidFill>
                   <a:srgbClr val="5B6573"/>
@@ -13339,6 +13105,7 @@
           <a:lstStyle xmlns:a="http://schemas.openxmlformats.org/drawingml/2006/main"/>
           <a:p xmlns:a="http://schemas.openxmlformats.org/drawingml/2006/main">
             <a:pPr algn="l">
+              <a:buNone/>
               <a:defRPr sz="2025" b="1">
                 <a:solidFill>
                   <a:srgbClr val="17365D"/>
@@ -13422,6 +13189,7 @@
           <a:lstStyle xmlns:a="http://schemas.openxmlformats.org/drawingml/2006/main"/>
           <a:p xmlns:a="http://schemas.openxmlformats.org/drawingml/2006/main">
             <a:pPr algn="l">
+              <a:buNone/>
               <a:defRPr sz="1050" b="1">
                 <a:solidFill>
                   <a:srgbClr val="5B6573"/>
@@ -13434,7 +13202,7 @@
                   <a:srgbClr val="5B6573"/>
                 </a:solidFill>
               </a:rPr>
-              <a:t>FY26 coverage</a:t>
+              <a:t>Latest FY26 outlook</a:t>
             </a:r>
           </a:p>
         </p:txBody>
@@ -13472,6 +13240,7 @@
           <a:lstStyle xmlns:a="http://schemas.openxmlformats.org/drawingml/2006/main"/>
           <a:p xmlns:a="http://schemas.openxmlformats.org/drawingml/2006/main">
             <a:pPr algn="l">
+              <a:buNone/>
               <a:defRPr sz="2025" b="1">
                 <a:solidFill>
                   <a:srgbClr val="17365D"/>
@@ -13555,6 +13324,7 @@
           <a:lstStyle xmlns:a="http://schemas.openxmlformats.org/drawingml/2006/main"/>
           <a:p xmlns:a="http://schemas.openxmlformats.org/drawingml/2006/main">
             <a:pPr algn="l">
+              <a:buNone/>
               <a:defRPr sz="1050" b="1">
                 <a:solidFill>
                   <a:srgbClr val="5B6573"/>
@@ -13567,7 +13337,7 @@
                   <a:srgbClr val="5B6573"/>
                 </a:solidFill>
               </a:rPr>
-              <a:t>FY27 coverage</a:t>
+              <a:t>Remaining FY26 revenue</a:t>
             </a:r>
           </a:p>
         </p:txBody>
@@ -13605,6 +13375,7 @@
           <a:lstStyle xmlns:a="http://schemas.openxmlformats.org/drawingml/2006/main"/>
           <a:p xmlns:a="http://schemas.openxmlformats.org/drawingml/2006/main">
             <a:pPr algn="l">
+              <a:buNone/>
               <a:defRPr sz="2025" b="1">
                 <a:solidFill>
                   <a:srgbClr val="17365D"/>
@@ -13688,6 +13459,7 @@
           <a:lstStyle xmlns:a="http://schemas.openxmlformats.org/drawingml/2006/main"/>
           <a:p xmlns:a="http://schemas.openxmlformats.org/drawingml/2006/main">
             <a:pPr algn="l">
+              <a:buNone/>
               <a:defRPr sz="1050" b="1">
                 <a:solidFill>
                   <a:srgbClr val="5B6573"/>
@@ -13700,7 +13472,7 @@
                   <a:srgbClr val="5B6573"/>
                 </a:solidFill>
               </a:rPr>
-              <a:t>First constrained month</a:t>
+              <a:t>Backlog coverage</a:t>
             </a:r>
           </a:p>
         </p:txBody>
@@ -13738,6 +13510,7 @@
           <a:lstStyle xmlns:a="http://schemas.openxmlformats.org/drawingml/2006/main"/>
           <a:p xmlns:a="http://schemas.openxmlformats.org/drawingml/2006/main">
             <a:pPr algn="l">
+              <a:buNone/>
               <a:defRPr sz="2025" b="1">
                 <a:solidFill>
                   <a:srgbClr val="17365D"/>
@@ -13788,6 +13561,7 @@
           <a:lstStyle xmlns:a="http://schemas.openxmlformats.org/drawingml/2006/main"/>
           <a:p xmlns:a="http://schemas.openxmlformats.org/drawingml/2006/main">
             <a:pPr algn="l">
+              <a:buNone/>
               <a:defRPr sz="1650" b="1">
                 <a:solidFill>
                   <a:srgbClr val="17365D"/>
@@ -13800,7 +13574,7 @@
                   <a:srgbClr val="17365D"/>
                 </a:solidFill>
               </a:rPr>
-              <a:t>Revenue coverage by business unit</a:t>
+              <a:t>Outlook comparison</a:t>
             </a:r>
           </a:p>
         </p:txBody>
@@ -13838,6 +13612,7 @@
           <a:lstStyle xmlns:a="http://schemas.openxmlformats.org/drawingml/2006/main"/>
           <a:p xmlns:a="http://schemas.openxmlformats.org/drawingml/2006/main">
             <a:pPr algn="l">
+              <a:buNone/>
               <a:defRPr sz="1350" b="1">
                 <a:solidFill>
                   <a:srgbClr val="1F2937"/>
@@ -13850,7 +13625,7 @@
                   <a:srgbClr val="1F2937"/>
                 </a:solidFill>
               </a:rPr>
-              <a:t>Construction</a:t>
+              <a:t>Latest outlook</a:t>
             </a:r>
           </a:p>
         </p:txBody>
@@ -13888,37 +13663,6 @@
       </p:sp>
       <p:sp>
         <p:nvSpPr>
-          <p:cNvPr id="22" name="outlook-fill-0">
-            <a:extLst xmlns:a="http://schemas.openxmlformats.org/drawingml/2006/main">
-              <a:ext uri="{FF2B5EF4-FFF2-40B4-BE49-F238E27FC236}">
-                <a16:creationId xmlns:a16="http://schemas.microsoft.com/office/drawing/2014/main" id="{07186658-9890-4F39-9EAC-0F425BE8EE0F}"/>
-              </a:ext>
-            </a:extLst>
-          </p:cNvPr>
-          <p:cNvSpPr>
-            <a:spLocks xmlns:a="http://schemas.openxmlformats.org/drawingml/2006/main" noGrp="1"/>
-          </p:cNvSpPr>
-          <p:nvPr/>
-        </p:nvSpPr>
-        <p:spPr>
-          <a:xfrm xmlns:a="http://schemas.openxmlformats.org/drawingml/2006/main">
-            <a:off x="2571750" y="3162300"/>
-            <a:ext cx="3429000" cy="266700"/>
-          </a:xfrm>
-          <a:prstGeom xmlns:a="http://schemas.openxmlformats.org/drawingml/2006/main" prst="rect">
-            <a:avLst/>
-          </a:prstGeom>
-          <a:solidFill xmlns:a="http://schemas.openxmlformats.org/drawingml/2006/main">
-            <a:srgbClr val="4472C4"/>
-          </a:solidFill>
-          <a:ln xmlns:a="http://schemas.openxmlformats.org/drawingml/2006/main" w="0">
-            <a:noFill/>
-            <a:prstDash val="solid"/>
-          </a:ln>
-        </p:spPr>
-      </p:sp>
-      <p:sp>
-        <p:nvSpPr>
           <p:cNvPr id="23" name="outlook-val-0">
             <a:extLst xmlns:a="http://schemas.openxmlformats.org/drawingml/2006/main">
               <a:ext uri="{FF2B5EF4-FFF2-40B4-BE49-F238E27FC236}">
@@ -13950,6 +13694,7 @@
           <a:lstStyle xmlns:a="http://schemas.openxmlformats.org/drawingml/2006/main"/>
           <a:p xmlns:a="http://schemas.openxmlformats.org/drawingml/2006/main">
             <a:pPr algn="l">
+              <a:buNone/>
               <a:defRPr sz="1200" b="1">
                 <a:solidFill>
                   <a:srgbClr val="17365D"/>
@@ -13962,7 +13707,7 @@
                   <a:srgbClr val="17365D"/>
                 </a:solidFill>
               </a:rPr>
-              <a:t>Refresh coverage</a:t>
+              <a:t>—</a:t>
             </a:r>
           </a:p>
         </p:txBody>
@@ -14000,6 +13745,7 @@
           <a:lstStyle xmlns:a="http://schemas.openxmlformats.org/drawingml/2006/main"/>
           <a:p xmlns:a="http://schemas.openxmlformats.org/drawingml/2006/main">
             <a:pPr algn="l">
+              <a:buNone/>
               <a:defRPr sz="1350" b="1">
                 <a:solidFill>
                   <a:srgbClr val="1F2937"/>
@@ -14012,7 +13758,7 @@
                   <a:srgbClr val="1F2937"/>
                 </a:solidFill>
               </a:rPr>
-              <a:t>Service</a:t>
+              <a:t>Revenue guidance low</a:t>
             </a:r>
           </a:p>
         </p:txBody>
@@ -14050,37 +13796,6 @@
       </p:sp>
       <p:sp>
         <p:nvSpPr>
-          <p:cNvPr id="26" name="outlook-fill-1">
-            <a:extLst xmlns:a="http://schemas.openxmlformats.org/drawingml/2006/main">
-              <a:ext uri="{FF2B5EF4-FFF2-40B4-BE49-F238E27FC236}">
-                <a16:creationId xmlns:a16="http://schemas.microsoft.com/office/drawing/2014/main" id="{A31CEBF3-4963-4CD6-A4D9-2EA09755AAFC}"/>
-              </a:ext>
-            </a:extLst>
-          </p:cNvPr>
-          <p:cNvSpPr>
-            <a:spLocks xmlns:a="http://schemas.openxmlformats.org/drawingml/2006/main" noGrp="1"/>
-          </p:cNvSpPr>
-          <p:nvPr/>
-        </p:nvSpPr>
-        <p:spPr>
-          <a:xfrm xmlns:a="http://schemas.openxmlformats.org/drawingml/2006/main">
-            <a:off x="2571750" y="4038600"/>
-            <a:ext cx="2952750" cy="266700"/>
-          </a:xfrm>
-          <a:prstGeom xmlns:a="http://schemas.openxmlformats.org/drawingml/2006/main" prst="rect">
-            <a:avLst/>
-          </a:prstGeom>
-          <a:solidFill xmlns:a="http://schemas.openxmlformats.org/drawingml/2006/main">
-            <a:srgbClr val="4472C4"/>
-          </a:solidFill>
-          <a:ln xmlns:a="http://schemas.openxmlformats.org/drawingml/2006/main" w="0">
-            <a:noFill/>
-            <a:prstDash val="solid"/>
-          </a:ln>
-        </p:spPr>
-      </p:sp>
-      <p:sp>
-        <p:nvSpPr>
           <p:cNvPr id="27" name="outlook-val-1">
             <a:extLst xmlns:a="http://schemas.openxmlformats.org/drawingml/2006/main">
               <a:ext uri="{FF2B5EF4-FFF2-40B4-BE49-F238E27FC236}">
@@ -14112,6 +13827,7 @@
           <a:lstStyle xmlns:a="http://schemas.openxmlformats.org/drawingml/2006/main"/>
           <a:p xmlns:a="http://schemas.openxmlformats.org/drawingml/2006/main">
             <a:pPr algn="l">
+              <a:buNone/>
               <a:defRPr sz="1200" b="1">
                 <a:solidFill>
                   <a:srgbClr val="17365D"/>
@@ -14124,7 +13840,7 @@
                   <a:srgbClr val="17365D"/>
                 </a:solidFill>
               </a:rPr>
-              <a:t>Refresh coverage</a:t>
+              <a:t>—</a:t>
             </a:r>
           </a:p>
         </p:txBody>
@@ -14162,6 +13878,7 @@
           <a:lstStyle xmlns:a="http://schemas.openxmlformats.org/drawingml/2006/main"/>
           <a:p xmlns:a="http://schemas.openxmlformats.org/drawingml/2006/main">
             <a:pPr algn="l">
+              <a:buNone/>
               <a:defRPr sz="1350" b="1">
                 <a:solidFill>
                   <a:srgbClr val="1F2937"/>
@@ -14174,7 +13891,7 @@
                   <a:srgbClr val="1F2937"/>
                 </a:solidFill>
               </a:rPr>
-              <a:t>Building Controls</a:t>
+              <a:t>Revenue guidance high</a:t>
             </a:r>
           </a:p>
         </p:txBody>
@@ -14212,37 +13929,6 @@
       </p:sp>
       <p:sp>
         <p:nvSpPr>
-          <p:cNvPr id="30" name="outlook-fill-2">
-            <a:extLst xmlns:a="http://schemas.openxmlformats.org/drawingml/2006/main">
-              <a:ext uri="{FF2B5EF4-FFF2-40B4-BE49-F238E27FC236}">
-                <a16:creationId xmlns:a16="http://schemas.microsoft.com/office/drawing/2014/main" id="{077A7F1C-F82D-48FB-9D1D-95F1256440CC}"/>
-              </a:ext>
-            </a:extLst>
-          </p:cNvPr>
-          <p:cNvSpPr>
-            <a:spLocks xmlns:a="http://schemas.openxmlformats.org/drawingml/2006/main" noGrp="1"/>
-          </p:cNvSpPr>
-          <p:nvPr/>
-        </p:nvSpPr>
-        <p:spPr>
-          <a:xfrm xmlns:a="http://schemas.openxmlformats.org/drawingml/2006/main">
-            <a:off x="2571750" y="4914900"/>
-            <a:ext cx="2476500" cy="266700"/>
-          </a:xfrm>
-          <a:prstGeom xmlns:a="http://schemas.openxmlformats.org/drawingml/2006/main" prst="rect">
-            <a:avLst/>
-          </a:prstGeom>
-          <a:solidFill xmlns:a="http://schemas.openxmlformats.org/drawingml/2006/main">
-            <a:srgbClr val="4472C4"/>
-          </a:solidFill>
-          <a:ln xmlns:a="http://schemas.openxmlformats.org/drawingml/2006/main" w="0">
-            <a:noFill/>
-            <a:prstDash val="solid"/>
-          </a:ln>
-        </p:spPr>
-      </p:sp>
-      <p:sp>
-        <p:nvSpPr>
           <p:cNvPr id="31" name="outlook-val-2">
             <a:extLst xmlns:a="http://schemas.openxmlformats.org/drawingml/2006/main">
               <a:ext uri="{FF2B5EF4-FFF2-40B4-BE49-F238E27FC236}">
@@ -14274,6 +13960,7 @@
           <a:lstStyle xmlns:a="http://schemas.openxmlformats.org/drawingml/2006/main"/>
           <a:p xmlns:a="http://schemas.openxmlformats.org/drawingml/2006/main">
             <a:pPr algn="l">
+              <a:buNone/>
               <a:defRPr sz="1200" b="1">
                 <a:solidFill>
                   <a:srgbClr val="17365D"/>
@@ -14286,7 +13973,7 @@
                   <a:srgbClr val="17365D"/>
                 </a:solidFill>
               </a:rPr>
-              <a:t>Refresh coverage</a:t>
+              <a:t>—</a:t>
             </a:r>
           </a:p>
         </p:txBody>
@@ -14355,6 +14042,7 @@
           <a:lstStyle xmlns:a="http://schemas.openxmlformats.org/drawingml/2006/main"/>
           <a:p xmlns:a="http://schemas.openxmlformats.org/drawingml/2006/main">
             <a:pPr algn="l">
+              <a:buNone/>
               <a:defRPr sz="1200" b="0">
                 <a:solidFill>
                   <a:srgbClr val="1F2937"/>
@@ -14367,7 +14055,7 @@
                   <a:srgbClr val="1F2937"/>
                 </a:solidFill>
               </a:rPr>
-              <a:t>State the latest outlook, quantified risks and opportunities, and capacity response without converting pipeline into backlog.</a:t>
+              <a:t>—</a:t>
             </a:r>
           </a:p>
         </p:txBody>
@@ -14403,7 +14091,7 @@
       </p:grpSpPr>
       <p:sp>
         <p:nvSpPr>
-          <p:cNvPr id="1" name="header-8">
+          <p:cNvPr id="91" name="header-8">
             <a:extLst xmlns:a="http://schemas.openxmlformats.org/drawingml/2006/main">
               <a:ext uri="{FF2B5EF4-FFF2-40B4-BE49-F238E27FC236}">
                 <a16:creationId xmlns:a16="http://schemas.microsoft.com/office/drawing/2014/main" id="{A1A24CE7-D019-4ED0-96CD-413E0E12A68E}"/>
@@ -14465,6 +14153,7 @@
           <a:lstStyle xmlns:a="http://schemas.openxmlformats.org/drawingml/2006/main"/>
           <a:p xmlns:a="http://schemas.openxmlformats.org/drawingml/2006/main">
             <a:pPr algn="l">
+              <a:buNone/>
               <a:defRPr sz="2625" b="1">
                 <a:solidFill>
                   <a:srgbClr val="17365D"/>
@@ -14477,57 +14166,7 @@
                   <a:srgbClr val="17365D"/>
                 </a:solidFill>
               </a:rPr>
-              <a:t>Risks and opportunities: convert the forecast into owned actions</a:t>
-            </a:r>
-          </a:p>
-        </p:txBody>
-      </p:sp>
-      <p:sp>
-        <p:nvSpPr>
-          <p:cNvPr id="3" name="draft-8">
-            <a:extLst xmlns:a="http://schemas.openxmlformats.org/drawingml/2006/main">
-              <a:ext uri="{FF2B5EF4-FFF2-40B4-BE49-F238E27FC236}">
-                <a16:creationId xmlns:a16="http://schemas.microsoft.com/office/drawing/2014/main" id="{79EA5B8A-2B1E-4D22-B8F9-6BFBD5CAC5F5}"/>
-              </a:ext>
-            </a:extLst>
-          </p:cNvPr>
-          <p:cNvSpPr>
-            <a:spLocks xmlns:a="http://schemas.openxmlformats.org/drawingml/2006/main" noGrp="1"/>
-          </p:cNvSpPr>
-          <p:nvPr/>
-        </p:nvSpPr>
-        <p:spPr>
-          <a:xfrm xmlns:a="http://schemas.openxmlformats.org/drawingml/2006/main">
-            <a:off x="9191625" y="495300"/>
-            <a:ext cx="2381250" cy="266700"/>
-          </a:xfrm>
-          <a:prstGeom xmlns:a="http://schemas.openxmlformats.org/drawingml/2006/main" prst="rect">
-            <a:avLst/>
-          </a:prstGeom>
-          <a:noFill xmlns:a="http://schemas.openxmlformats.org/drawingml/2006/main"/>
-          <a:ln xmlns:a="http://schemas.openxmlformats.org/drawingml/2006/main" w="0">
-            <a:noFill/>
-            <a:prstDash val="solid"/>
-          </a:ln>
-        </p:spPr>
-        <p:txBody>
-          <a:bodyPr xmlns:a="http://schemas.openxmlformats.org/drawingml/2006/main" anchor="ctr"/>
-          <a:lstStyle xmlns:a="http://schemas.openxmlformats.org/drawingml/2006/main"/>
-          <a:p xmlns:a="http://schemas.openxmlformats.org/drawingml/2006/main">
-            <a:pPr algn="r">
-              <a:defRPr sz="1050" b="1">
-                <a:solidFill>
-                  <a:srgbClr val="B91C1C"/>
-                </a:solidFill>
-              </a:defRPr>
-            </a:pPr>
-            <a:r>
-              <a:rPr sz="1050" b="1">
-                <a:solidFill>
-                  <a:srgbClr val="B91C1C"/>
-                </a:solidFill>
-              </a:rPr>
-              <a:t>DRAFT — DATA NOT REFRESHED</a:t>
+              <a:t>Risks and management actions</a:t>
             </a:r>
           </a:p>
         </p:txBody>
@@ -14596,6 +14235,7 @@
           <a:lstStyle xmlns:a="http://schemas.openxmlformats.org/drawingml/2006/main"/>
           <a:p xmlns:a="http://schemas.openxmlformats.org/drawingml/2006/main">
             <a:pPr algn="l">
+              <a:buNone/>
               <a:defRPr sz="825" b="0">
                 <a:solidFill>
                   <a:srgbClr val="5B6573"/>
@@ -14608,7 +14248,7 @@
                   <a:srgbClr val="5B6573"/>
                 </a:solidFill>
               </a:rPr>
-              <a:t>Alder Ridge Mechanical • June 2026 executive performance review • Internal working</a:t>
+              <a:t>Alder Ridge Mechanical • June 2026</a:t>
             </a:r>
           </a:p>
         </p:txBody>
@@ -14646,6 +14286,7 @@
           <a:lstStyle xmlns:a="http://schemas.openxmlformats.org/drawingml/2006/main"/>
           <a:p xmlns:a="http://schemas.openxmlformats.org/drawingml/2006/main">
             <a:pPr algn="r">
+              <a:buNone/>
               <a:defRPr sz="825" b="0">
                 <a:solidFill>
                   <a:srgbClr val="5B6573"/>
@@ -14729,6 +14370,7 @@
           <a:lstStyle xmlns:a="http://schemas.openxmlformats.org/drawingml/2006/main"/>
           <a:p xmlns:a="http://schemas.openxmlformats.org/drawingml/2006/main">
             <a:pPr algn="l">
+              <a:buNone/>
               <a:defRPr sz="1125" b="1">
                 <a:solidFill>
                   <a:srgbClr val="FFFFFF"/>
@@ -14812,6 +14454,7 @@
           <a:lstStyle xmlns:a="http://schemas.openxmlformats.org/drawingml/2006/main"/>
           <a:p xmlns:a="http://schemas.openxmlformats.org/drawingml/2006/main">
             <a:pPr algn="ctr">
+              <a:buNone/>
               <a:defRPr sz="1125" b="1">
                 <a:solidFill>
                   <a:srgbClr val="FFFFFF"/>
@@ -14895,6 +14538,7 @@
           <a:lstStyle xmlns:a="http://schemas.openxmlformats.org/drawingml/2006/main"/>
           <a:p xmlns:a="http://schemas.openxmlformats.org/drawingml/2006/main">
             <a:pPr algn="ctr">
+              <a:buNone/>
               <a:defRPr sz="1125" b="1">
                 <a:solidFill>
                   <a:srgbClr val="FFFFFF"/>
@@ -14978,6 +14622,7 @@
           <a:lstStyle xmlns:a="http://schemas.openxmlformats.org/drawingml/2006/main"/>
           <a:p xmlns:a="http://schemas.openxmlformats.org/drawingml/2006/main">
             <a:pPr algn="ctr">
+              <a:buNone/>
               <a:defRPr sz="1125" b="1">
                 <a:solidFill>
                   <a:srgbClr val="FFFFFF"/>
@@ -15061,6 +14706,7 @@
           <a:lstStyle xmlns:a="http://schemas.openxmlformats.org/drawingml/2006/main"/>
           <a:p xmlns:a="http://schemas.openxmlformats.org/drawingml/2006/main">
             <a:pPr algn="ctr">
+              <a:buNone/>
               <a:defRPr sz="1125" b="1">
                 <a:solidFill>
                   <a:srgbClr val="FFFFFF"/>
@@ -15144,6 +14790,7 @@
           <a:lstStyle xmlns:a="http://schemas.openxmlformats.org/drawingml/2006/main"/>
           <a:p xmlns:a="http://schemas.openxmlformats.org/drawingml/2006/main">
             <a:pPr algn="ctr">
+              <a:buNone/>
               <a:defRPr sz="1125" b="1">
                 <a:solidFill>
                   <a:srgbClr val="FFFFFF"/>
@@ -15227,6 +14874,7 @@
           <a:lstStyle xmlns:a="http://schemas.openxmlformats.org/drawingml/2006/main"/>
           <a:p xmlns:a="http://schemas.openxmlformats.org/drawingml/2006/main">
             <a:pPr algn="l">
+              <a:buNone/>
               <a:defRPr sz="1200" b="0">
                 <a:solidFill>
                   <a:srgbClr val="1F2937"/>
@@ -15239,7 +14887,7 @@
                   <a:srgbClr val="1F2937"/>
                 </a:solidFill>
               </a:rPr>
-              <a:t>Supported risk or opportunity</a:t>
+              <a:t>—</a:t>
             </a:r>
           </a:p>
         </p:txBody>
@@ -15310,6 +14958,7 @@
           <a:lstStyle xmlns:a="http://schemas.openxmlformats.org/drawingml/2006/main"/>
           <a:p xmlns:a="http://schemas.openxmlformats.org/drawingml/2006/main">
             <a:pPr algn="ctr">
+              <a:buNone/>
               <a:defRPr sz="1350" b="0">
                 <a:solidFill>
                   <a:srgbClr val="17365D"/>
@@ -15393,6 +15042,7 @@
           <a:lstStyle xmlns:a="http://schemas.openxmlformats.org/drawingml/2006/main"/>
           <a:p xmlns:a="http://schemas.openxmlformats.org/drawingml/2006/main">
             <a:pPr algn="ctr">
+              <a:buNone/>
               <a:defRPr sz="1350" b="0">
                 <a:solidFill>
                   <a:srgbClr val="17365D"/>
@@ -15476,6 +15126,7 @@
           <a:lstStyle xmlns:a="http://schemas.openxmlformats.org/drawingml/2006/main"/>
           <a:p xmlns:a="http://schemas.openxmlformats.org/drawingml/2006/main">
             <a:pPr algn="ctr">
+              <a:buNone/>
               <a:defRPr sz="1350" b="0">
                 <a:solidFill>
                   <a:srgbClr val="17365D"/>
@@ -15559,6 +15210,7 @@
           <a:lstStyle xmlns:a="http://schemas.openxmlformats.org/drawingml/2006/main"/>
           <a:p xmlns:a="http://schemas.openxmlformats.org/drawingml/2006/main">
             <a:pPr algn="ctr">
+              <a:buNone/>
               <a:defRPr sz="1350" b="0">
                 <a:solidFill>
                   <a:srgbClr val="17365D"/>
@@ -15642,6 +15294,7 @@
           <a:lstStyle xmlns:a="http://schemas.openxmlformats.org/drawingml/2006/main"/>
           <a:p xmlns:a="http://schemas.openxmlformats.org/drawingml/2006/main">
             <a:pPr algn="ctr">
+              <a:buNone/>
               <a:defRPr sz="1350" b="0">
                 <a:solidFill>
                   <a:srgbClr val="17365D"/>
@@ -15725,6 +15378,7 @@
           <a:lstStyle xmlns:a="http://schemas.openxmlformats.org/drawingml/2006/main"/>
           <a:p xmlns:a="http://schemas.openxmlformats.org/drawingml/2006/main">
             <a:pPr algn="l">
+              <a:buNone/>
               <a:defRPr sz="1200" b="0">
                 <a:solidFill>
                   <a:srgbClr val="1F2937"/>
@@ -15737,7 +15391,7 @@
                   <a:srgbClr val="1F2937"/>
                 </a:solidFill>
               </a:rPr>
-              <a:t>Supported risk or opportunity</a:t>
+              <a:t>—</a:t>
             </a:r>
           </a:p>
         </p:txBody>
@@ -15808,6 +15462,7 @@
           <a:lstStyle xmlns:a="http://schemas.openxmlformats.org/drawingml/2006/main"/>
           <a:p xmlns:a="http://schemas.openxmlformats.org/drawingml/2006/main">
             <a:pPr algn="ctr">
+              <a:buNone/>
               <a:defRPr sz="1350" b="0">
                 <a:solidFill>
                   <a:srgbClr val="17365D"/>
@@ -15891,6 +15546,7 @@
           <a:lstStyle xmlns:a="http://schemas.openxmlformats.org/drawingml/2006/main"/>
           <a:p xmlns:a="http://schemas.openxmlformats.org/drawingml/2006/main">
             <a:pPr algn="ctr">
+              <a:buNone/>
               <a:defRPr sz="1350" b="0">
                 <a:solidFill>
                   <a:srgbClr val="17365D"/>
@@ -15974,6 +15630,7 @@
           <a:lstStyle xmlns:a="http://schemas.openxmlformats.org/drawingml/2006/main"/>
           <a:p xmlns:a="http://schemas.openxmlformats.org/drawingml/2006/main">
             <a:pPr algn="ctr">
+              <a:buNone/>
               <a:defRPr sz="1350" b="0">
                 <a:solidFill>
                   <a:srgbClr val="17365D"/>
@@ -16057,6 +15714,7 @@
           <a:lstStyle xmlns:a="http://schemas.openxmlformats.org/drawingml/2006/main"/>
           <a:p xmlns:a="http://schemas.openxmlformats.org/drawingml/2006/main">
             <a:pPr algn="ctr">
+              <a:buNone/>
               <a:defRPr sz="1350" b="0">
                 <a:solidFill>
                   <a:srgbClr val="17365D"/>
@@ -16140,6 +15798,7 @@
           <a:lstStyle xmlns:a="http://schemas.openxmlformats.org/drawingml/2006/main"/>
           <a:p xmlns:a="http://schemas.openxmlformats.org/drawingml/2006/main">
             <a:pPr algn="ctr">
+              <a:buNone/>
               <a:defRPr sz="1350" b="0">
                 <a:solidFill>
                   <a:srgbClr val="17365D"/>
@@ -16223,6 +15882,7 @@
           <a:lstStyle xmlns:a="http://schemas.openxmlformats.org/drawingml/2006/main"/>
           <a:p xmlns:a="http://schemas.openxmlformats.org/drawingml/2006/main">
             <a:pPr algn="l">
+              <a:buNone/>
               <a:defRPr sz="1200" b="0">
                 <a:solidFill>
                   <a:srgbClr val="1F2937"/>
@@ -16235,7 +15895,7 @@
                   <a:srgbClr val="1F2937"/>
                 </a:solidFill>
               </a:rPr>
-              <a:t>Supported risk or opportunity</a:t>
+              <a:t>—</a:t>
             </a:r>
           </a:p>
         </p:txBody>
@@ -16306,6 +15966,7 @@
           <a:lstStyle xmlns:a="http://schemas.openxmlformats.org/drawingml/2006/main"/>
           <a:p xmlns:a="http://schemas.openxmlformats.org/drawingml/2006/main">
             <a:pPr algn="ctr">
+              <a:buNone/>
               <a:defRPr sz="1350" b="0">
                 <a:solidFill>
                   <a:srgbClr val="17365D"/>
@@ -16389,6 +16050,7 @@
           <a:lstStyle xmlns:a="http://schemas.openxmlformats.org/drawingml/2006/main"/>
           <a:p xmlns:a="http://schemas.openxmlformats.org/drawingml/2006/main">
             <a:pPr algn="ctr">
+              <a:buNone/>
               <a:defRPr sz="1350" b="0">
                 <a:solidFill>
                   <a:srgbClr val="17365D"/>
@@ -16472,6 +16134,7 @@
           <a:lstStyle xmlns:a="http://schemas.openxmlformats.org/drawingml/2006/main"/>
           <a:p xmlns:a="http://schemas.openxmlformats.org/drawingml/2006/main">
             <a:pPr algn="ctr">
+              <a:buNone/>
               <a:defRPr sz="1350" b="0">
                 <a:solidFill>
                   <a:srgbClr val="17365D"/>
@@ -16555,6 +16218,7 @@
           <a:lstStyle xmlns:a="http://schemas.openxmlformats.org/drawingml/2006/main"/>
           <a:p xmlns:a="http://schemas.openxmlformats.org/drawingml/2006/main">
             <a:pPr algn="ctr">
+              <a:buNone/>
               <a:defRPr sz="1350" b="0">
                 <a:solidFill>
                   <a:srgbClr val="17365D"/>
@@ -16638,6 +16302,7 @@
           <a:lstStyle xmlns:a="http://schemas.openxmlformats.org/drawingml/2006/main"/>
           <a:p xmlns:a="http://schemas.openxmlformats.org/drawingml/2006/main">
             <a:pPr algn="ctr">
+              <a:buNone/>
               <a:defRPr sz="1350" b="0">
                 <a:solidFill>
                   <a:srgbClr val="17365D"/>
@@ -16721,6 +16386,7 @@
           <a:lstStyle xmlns:a="http://schemas.openxmlformats.org/drawingml/2006/main"/>
           <a:p xmlns:a="http://schemas.openxmlformats.org/drawingml/2006/main">
             <a:pPr algn="l">
+              <a:buNone/>
               <a:defRPr sz="1200" b="0">
                 <a:solidFill>
                   <a:srgbClr val="1F2937"/>
@@ -16733,7 +16399,7 @@
                   <a:srgbClr val="1F2937"/>
                 </a:solidFill>
               </a:rPr>
-              <a:t>Supported risk or opportunity</a:t>
+              <a:t>—</a:t>
             </a:r>
           </a:p>
         </p:txBody>
@@ -16804,6 +16470,7 @@
           <a:lstStyle xmlns:a="http://schemas.openxmlformats.org/drawingml/2006/main"/>
           <a:p xmlns:a="http://schemas.openxmlformats.org/drawingml/2006/main">
             <a:pPr algn="ctr">
+              <a:buNone/>
               <a:defRPr sz="1350" b="0">
                 <a:solidFill>
                   <a:srgbClr val="17365D"/>
@@ -16887,6 +16554,7 @@
           <a:lstStyle xmlns:a="http://schemas.openxmlformats.org/drawingml/2006/main"/>
           <a:p xmlns:a="http://schemas.openxmlformats.org/drawingml/2006/main">
             <a:pPr algn="ctr">
+              <a:buNone/>
               <a:defRPr sz="1350" b="0">
                 <a:solidFill>
                   <a:srgbClr val="17365D"/>
@@ -16970,6 +16638,7 @@
           <a:lstStyle xmlns:a="http://schemas.openxmlformats.org/drawingml/2006/main"/>
           <a:p xmlns:a="http://schemas.openxmlformats.org/drawingml/2006/main">
             <a:pPr algn="ctr">
+              <a:buNone/>
               <a:defRPr sz="1350" b="0">
                 <a:solidFill>
                   <a:srgbClr val="17365D"/>
@@ -17053,6 +16722,7 @@
           <a:lstStyle xmlns:a="http://schemas.openxmlformats.org/drawingml/2006/main"/>
           <a:p xmlns:a="http://schemas.openxmlformats.org/drawingml/2006/main">
             <a:pPr algn="ctr">
+              <a:buNone/>
               <a:defRPr sz="1350" b="0">
                 <a:solidFill>
                   <a:srgbClr val="17365D"/>
@@ -17136,6 +16806,7 @@
           <a:lstStyle xmlns:a="http://schemas.openxmlformats.org/drawingml/2006/main"/>
           <a:p xmlns:a="http://schemas.openxmlformats.org/drawingml/2006/main">
             <a:pPr algn="ctr">
+              <a:buNone/>
               <a:defRPr sz="1350" b="0">
                 <a:solidFill>
                   <a:srgbClr val="17365D"/>
@@ -17219,6 +16890,7 @@
           <a:lstStyle xmlns:a="http://schemas.openxmlformats.org/drawingml/2006/main"/>
           <a:p xmlns:a="http://schemas.openxmlformats.org/drawingml/2006/main">
             <a:pPr algn="l">
+              <a:buNone/>
               <a:defRPr sz="1200" b="0">
                 <a:solidFill>
                   <a:srgbClr val="1F2937"/>
@@ -17231,7 +16903,7 @@
                   <a:srgbClr val="1F2937"/>
                 </a:solidFill>
               </a:rPr>
-              <a:t>Supported risk or opportunity</a:t>
+              <a:t>—</a:t>
             </a:r>
           </a:p>
         </p:txBody>
@@ -17302,6 +16974,7 @@
           <a:lstStyle xmlns:a="http://schemas.openxmlformats.org/drawingml/2006/main"/>
           <a:p xmlns:a="http://schemas.openxmlformats.org/drawingml/2006/main">
             <a:pPr algn="ctr">
+              <a:buNone/>
               <a:defRPr sz="1350" b="0">
                 <a:solidFill>
                   <a:srgbClr val="17365D"/>
@@ -17385,6 +17058,7 @@
           <a:lstStyle xmlns:a="http://schemas.openxmlformats.org/drawingml/2006/main"/>
           <a:p xmlns:a="http://schemas.openxmlformats.org/drawingml/2006/main">
             <a:pPr algn="ctr">
+              <a:buNone/>
               <a:defRPr sz="1350" b="0">
                 <a:solidFill>
                   <a:srgbClr val="17365D"/>
@@ -17468,6 +17142,7 @@
           <a:lstStyle xmlns:a="http://schemas.openxmlformats.org/drawingml/2006/main"/>
           <a:p xmlns:a="http://schemas.openxmlformats.org/drawingml/2006/main">
             <a:pPr algn="ctr">
+              <a:buNone/>
               <a:defRPr sz="1350" b="0">
                 <a:solidFill>
                   <a:srgbClr val="17365D"/>
@@ -17551,6 +17226,7 @@
           <a:lstStyle xmlns:a="http://schemas.openxmlformats.org/drawingml/2006/main"/>
           <a:p xmlns:a="http://schemas.openxmlformats.org/drawingml/2006/main">
             <a:pPr algn="ctr">
+              <a:buNone/>
               <a:defRPr sz="1350" b="0">
                 <a:solidFill>
                   <a:srgbClr val="17365D"/>
@@ -17634,6 +17310,7 @@
           <a:lstStyle xmlns:a="http://schemas.openxmlformats.org/drawingml/2006/main"/>
           <a:p xmlns:a="http://schemas.openxmlformats.org/drawingml/2006/main">
             <a:pPr algn="ctr">
+              <a:buNone/>
               <a:defRPr sz="1350" b="0">
                 <a:solidFill>
                   <a:srgbClr val="17365D"/>
@@ -17717,6 +17394,7 @@
           <a:lstStyle xmlns:a="http://schemas.openxmlformats.org/drawingml/2006/main"/>
           <a:p xmlns:a="http://schemas.openxmlformats.org/drawingml/2006/main">
             <a:pPr algn="l">
+              <a:buNone/>
               <a:defRPr sz="1200" b="0">
                 <a:solidFill>
                   <a:srgbClr val="1F2937"/>
@@ -17729,7 +17407,7 @@
                   <a:srgbClr val="1F2937"/>
                 </a:solidFill>
               </a:rPr>
-              <a:t>Supported risk or opportunity</a:t>
+              <a:t>—</a:t>
             </a:r>
           </a:p>
         </p:txBody>
@@ -17800,6 +17478,7 @@
           <a:lstStyle xmlns:a="http://schemas.openxmlformats.org/drawingml/2006/main"/>
           <a:p xmlns:a="http://schemas.openxmlformats.org/drawingml/2006/main">
             <a:pPr algn="ctr">
+              <a:buNone/>
               <a:defRPr sz="1350" b="0">
                 <a:solidFill>
                   <a:srgbClr val="17365D"/>
@@ -17883,6 +17562,7 @@
           <a:lstStyle xmlns:a="http://schemas.openxmlformats.org/drawingml/2006/main"/>
           <a:p xmlns:a="http://schemas.openxmlformats.org/drawingml/2006/main">
             <a:pPr algn="ctr">
+              <a:buNone/>
               <a:defRPr sz="1350" b="0">
                 <a:solidFill>
                   <a:srgbClr val="17365D"/>
@@ -17966,6 +17646,7 @@
           <a:lstStyle xmlns:a="http://schemas.openxmlformats.org/drawingml/2006/main"/>
           <a:p xmlns:a="http://schemas.openxmlformats.org/drawingml/2006/main">
             <a:pPr algn="ctr">
+              <a:buNone/>
               <a:defRPr sz="1350" b="0">
                 <a:solidFill>
                   <a:srgbClr val="17365D"/>
@@ -18049,6 +17730,7 @@
           <a:lstStyle xmlns:a="http://schemas.openxmlformats.org/drawingml/2006/main"/>
           <a:p xmlns:a="http://schemas.openxmlformats.org/drawingml/2006/main">
             <a:pPr algn="ctr">
+              <a:buNone/>
               <a:defRPr sz="1350" b="0">
                 <a:solidFill>
                   <a:srgbClr val="17365D"/>
@@ -18132,6 +17814,7 @@
           <a:lstStyle xmlns:a="http://schemas.openxmlformats.org/drawingml/2006/main"/>
           <a:p xmlns:a="http://schemas.openxmlformats.org/drawingml/2006/main">
             <a:pPr algn="ctr">
+              <a:buNone/>
               <a:defRPr sz="1350" b="0">
                 <a:solidFill>
                   <a:srgbClr val="17365D"/>
@@ -18180,7 +17863,7 @@
       </p:grpSpPr>
       <p:sp>
         <p:nvSpPr>
-          <p:cNvPr id="1" name="header-9">
+          <p:cNvPr id="27" name="header-9">
             <a:extLst xmlns:a="http://schemas.openxmlformats.org/drawingml/2006/main">
               <a:ext uri="{FF2B5EF4-FFF2-40B4-BE49-F238E27FC236}">
                 <a16:creationId xmlns:a16="http://schemas.microsoft.com/office/drawing/2014/main" id="{F837C503-B140-4C35-BF91-E603F40A46F5}"/>
@@ -18242,6 +17925,7 @@
           <a:lstStyle xmlns:a="http://schemas.openxmlformats.org/drawingml/2006/main"/>
           <a:p xmlns:a="http://schemas.openxmlformats.org/drawingml/2006/main">
             <a:pPr algn="l">
+              <a:buNone/>
               <a:defRPr sz="2625" b="1">
                 <a:solidFill>
                   <a:srgbClr val="17365D"/>
@@ -18254,57 +17938,7 @@
                   <a:srgbClr val="17365D"/>
                 </a:solidFill>
               </a:rPr>
-              <a:t>Numerical tie-out and controlling sources</a:t>
-            </a:r>
-          </a:p>
-        </p:txBody>
-      </p:sp>
-      <p:sp>
-        <p:nvSpPr>
-          <p:cNvPr id="3" name="draft-9">
-            <a:extLst xmlns:a="http://schemas.openxmlformats.org/drawingml/2006/main">
-              <a:ext uri="{FF2B5EF4-FFF2-40B4-BE49-F238E27FC236}">
-                <a16:creationId xmlns:a16="http://schemas.microsoft.com/office/drawing/2014/main" id="{6071EA5C-A2F0-4AC5-BD31-3615BAC7B873}"/>
-              </a:ext>
-            </a:extLst>
-          </p:cNvPr>
-          <p:cNvSpPr>
-            <a:spLocks xmlns:a="http://schemas.openxmlformats.org/drawingml/2006/main" noGrp="1"/>
-          </p:cNvSpPr>
-          <p:nvPr/>
-        </p:nvSpPr>
-        <p:spPr>
-          <a:xfrm xmlns:a="http://schemas.openxmlformats.org/drawingml/2006/main">
-            <a:off x="9191625" y="495300"/>
-            <a:ext cx="2381250" cy="266700"/>
-          </a:xfrm>
-          <a:prstGeom xmlns:a="http://schemas.openxmlformats.org/drawingml/2006/main" prst="rect">
-            <a:avLst/>
-          </a:prstGeom>
-          <a:noFill xmlns:a="http://schemas.openxmlformats.org/drawingml/2006/main"/>
-          <a:ln xmlns:a="http://schemas.openxmlformats.org/drawingml/2006/main" w="0">
-            <a:noFill/>
-            <a:prstDash val="solid"/>
-          </a:ln>
-        </p:spPr>
-        <p:txBody>
-          <a:bodyPr xmlns:a="http://schemas.openxmlformats.org/drawingml/2006/main" anchor="ctr"/>
-          <a:lstStyle xmlns:a="http://schemas.openxmlformats.org/drawingml/2006/main"/>
-          <a:p xmlns:a="http://schemas.openxmlformats.org/drawingml/2006/main">
-            <a:pPr algn="r">
-              <a:defRPr sz="1050" b="1">
-                <a:solidFill>
-                  <a:srgbClr val="B91C1C"/>
-                </a:solidFill>
-              </a:defRPr>
-            </a:pPr>
-            <a:r>
-              <a:rPr sz="1050" b="1">
-                <a:solidFill>
-                  <a:srgbClr val="B91C1C"/>
-                </a:solidFill>
-              </a:rPr>
-              <a:t>DRAFT — DATA NOT REFRESHED</a:t>
+              <a:t>Reconciliation and sources</a:t>
             </a:r>
           </a:p>
         </p:txBody>
@@ -18373,6 +18007,7 @@
           <a:lstStyle xmlns:a="http://schemas.openxmlformats.org/drawingml/2006/main"/>
           <a:p xmlns:a="http://schemas.openxmlformats.org/drawingml/2006/main">
             <a:pPr algn="l">
+              <a:buNone/>
               <a:defRPr sz="825" b="0">
                 <a:solidFill>
                   <a:srgbClr val="5B6573"/>
@@ -18385,7 +18020,7 @@
                   <a:srgbClr val="5B6573"/>
                 </a:solidFill>
               </a:rPr>
-              <a:t>Alder Ridge Mechanical • June 2026 executive performance review • Internal working</a:t>
+              <a:t>Alder Ridge Mechanical • June 2026</a:t>
             </a:r>
           </a:p>
         </p:txBody>
@@ -18423,6 +18058,7 @@
           <a:lstStyle xmlns:a="http://schemas.openxmlformats.org/drawingml/2006/main"/>
           <a:p xmlns:a="http://schemas.openxmlformats.org/drawingml/2006/main">
             <a:pPr algn="r">
+              <a:buNone/>
               <a:defRPr sz="825" b="0">
                 <a:solidFill>
                   <a:srgbClr val="5B6573"/>
@@ -18473,6 +18109,7 @@
           <a:lstStyle xmlns:a="http://schemas.openxmlformats.org/drawingml/2006/main"/>
           <a:p xmlns:a="http://schemas.openxmlformats.org/drawingml/2006/main">
             <a:pPr algn="l">
+              <a:buNone/>
               <a:defRPr sz="1650" b="1">
                 <a:solidFill>
                   <a:srgbClr val="17365D"/>
@@ -18485,7 +18122,7 @@
                   <a:srgbClr val="17365D"/>
                 </a:solidFill>
               </a:rPr>
-              <a:t>Close controls</a:t>
+              <a:t>Reconciliation controls</a:t>
             </a:r>
           </a:p>
         </p:txBody>
@@ -18556,6 +18193,7 @@
           <a:lstStyle xmlns:a="http://schemas.openxmlformats.org/drawingml/2006/main"/>
           <a:p xmlns:a="http://schemas.openxmlformats.org/drawingml/2006/main">
             <a:pPr algn="l">
+              <a:buNone/>
               <a:defRPr sz="1200" b="0">
                 <a:solidFill>
                   <a:srgbClr val="1F2937"/>
@@ -18568,7 +18206,7 @@
                   <a:srgbClr val="1F2937"/>
                 </a:solidFill>
               </a:rPr>
-              <a:t>Revenue bridge to Q2 P&amp;L</a:t>
+              <a:t>Revenue</a:t>
             </a:r>
           </a:p>
         </p:txBody>
@@ -18606,6 +18244,7 @@
           <a:lstStyle xmlns:a="http://schemas.openxmlformats.org/drawingml/2006/main"/>
           <a:p xmlns:a="http://schemas.openxmlformats.org/drawingml/2006/main">
             <a:pPr algn="r">
+              <a:buNone/>
               <a:defRPr sz="1500" b="1">
                 <a:solidFill>
                   <a:srgbClr val="17365D"/>
@@ -18689,6 +18328,7 @@
           <a:lstStyle xmlns:a="http://schemas.openxmlformats.org/drawingml/2006/main"/>
           <a:p xmlns:a="http://schemas.openxmlformats.org/drawingml/2006/main">
             <a:pPr algn="l">
+              <a:buNone/>
               <a:defRPr sz="1200" b="0">
                 <a:solidFill>
                   <a:srgbClr val="1F2937"/>
@@ -18701,7 +18341,7 @@
                   <a:srgbClr val="1F2937"/>
                 </a:solidFill>
               </a:rPr>
-              <a:t>Adjusted EBITDA bridge</a:t>
+              <a:t>Adjusted EBITDA</a:t>
             </a:r>
           </a:p>
         </p:txBody>
@@ -18739,6 +18379,7 @@
           <a:lstStyle xmlns:a="http://schemas.openxmlformats.org/drawingml/2006/main"/>
           <a:p xmlns:a="http://schemas.openxmlformats.org/drawingml/2006/main">
             <a:pPr algn="r">
+              <a:buNone/>
               <a:defRPr sz="1500" b="1">
                 <a:solidFill>
                   <a:srgbClr val="17365D"/>
@@ -18822,6 +18463,7 @@
           <a:lstStyle xmlns:a="http://schemas.openxmlformats.org/drawingml/2006/main"/>
           <a:p xmlns:a="http://schemas.openxmlformats.org/drawingml/2006/main">
             <a:pPr algn="l">
+              <a:buNone/>
               <a:defRPr sz="1200" b="0">
                 <a:solidFill>
                   <a:srgbClr val="1F2937"/>
@@ -18834,7 +18476,7 @@
                   <a:srgbClr val="1F2937"/>
                 </a:solidFill>
               </a:rPr>
-              <a:t>Cash roll-forward</a:t>
+              <a:t>Cash flow</a:t>
             </a:r>
           </a:p>
         </p:txBody>
@@ -18872,6 +18514,7 @@
           <a:lstStyle xmlns:a="http://schemas.openxmlformats.org/drawingml/2006/main"/>
           <a:p xmlns:a="http://schemas.openxmlformats.org/drawingml/2006/main">
             <a:pPr algn="r">
+              <a:buNone/>
               <a:defRPr sz="1500" b="1">
                 <a:solidFill>
                   <a:srgbClr val="17365D"/>
@@ -18955,6 +18598,7 @@
           <a:lstStyle xmlns:a="http://schemas.openxmlformats.org/drawingml/2006/main"/>
           <a:p xmlns:a="http://schemas.openxmlformats.org/drawingml/2006/main">
             <a:pPr algn="l">
+              <a:buNone/>
               <a:defRPr sz="1200" b="0">
                 <a:solidFill>
                   <a:srgbClr val="1F2937"/>
@@ -18967,7 +18611,7 @@
                   <a:srgbClr val="1F2937"/>
                 </a:solidFill>
               </a:rPr>
-              <a:t>Backlog to signed contract population</a:t>
+              <a:t>Backlog</a:t>
             </a:r>
           </a:p>
         </p:txBody>
@@ -19005,6 +18649,7 @@
           <a:lstStyle xmlns:a="http://schemas.openxmlformats.org/drawingml/2006/main"/>
           <a:p xmlns:a="http://schemas.openxmlformats.org/drawingml/2006/main">
             <a:pPr algn="r">
+              <a:buNone/>
               <a:defRPr sz="1500" b="1">
                 <a:solidFill>
                   <a:srgbClr val="17365D"/>
@@ -19088,6 +18733,7 @@
           <a:lstStyle xmlns:a="http://schemas.openxmlformats.org/drawingml/2006/main"/>
           <a:p xmlns:a="http://schemas.openxmlformats.org/drawingml/2006/main">
             <a:pPr algn="l">
+              <a:buNone/>
               <a:defRPr sz="1200" b="1">
                 <a:solidFill>
                   <a:srgbClr val="1F2937"/>
@@ -19100,7 +18746,7 @@
                   <a:srgbClr val="1F2937"/>
                 </a:solidFill>
               </a:rPr>
-              <a:t>Latest forecast to executive summary</a:t>
+              <a:t>Outlook</a:t>
             </a:r>
           </a:p>
         </p:txBody>
@@ -19138,6 +18784,7 @@
           <a:lstStyle xmlns:a="http://schemas.openxmlformats.org/drawingml/2006/main"/>
           <a:p xmlns:a="http://schemas.openxmlformats.org/drawingml/2006/main">
             <a:pPr algn="r">
+              <a:buNone/>
               <a:defRPr sz="1500" b="1">
                 <a:solidFill>
                   <a:srgbClr val="17365D"/>
@@ -19188,6 +18835,7 @@
           <a:lstStyle xmlns:a="http://schemas.openxmlformats.org/drawingml/2006/main"/>
           <a:p xmlns:a="http://schemas.openxmlformats.org/drawingml/2006/main">
             <a:pPr algn="l">
+              <a:buNone/>
               <a:defRPr sz="1650" b="1">
                 <a:solidFill>
                   <a:srgbClr val="17365D"/>
@@ -19237,108 +18885,8 @@
           <a:bodyPr xmlns:a="http://schemas.openxmlformats.org/drawingml/2006/main" anchor="ctr"/>
           <a:lstStyle xmlns:a="http://schemas.openxmlformats.org/drawingml/2006/main"/>
           <a:p xmlns:a="http://schemas.openxmlformats.org/drawingml/2006/main">
-            <a:pPr algn="l">
-              <a:defRPr sz="1275" b="0">
-                <a:solidFill>
-                  <a:srgbClr val="1F2937"/>
-                </a:solidFill>
-              </a:defRPr>
-            </a:pPr>
-            <a:r>
-              <a:rPr sz="1275" b="0">
-                <a:solidFill>
-                  <a:srgbClr val="1F2937"/>
-                </a:solidFill>
-              </a:rPr>
-              <a:t>• Vista ERP: profit_and_loss by department</a:t>
-            </a:r>
-          </a:p>
-          <a:p xmlns:a="http://schemas.openxmlformats.org/drawingml/2006/main">
-            <a:r>
-              <a:t/>
-            </a:r>
-          </a:p>
-          <a:p xmlns:a="http://schemas.openxmlformats.org/drawingml/2006/main">
-            <a:pPr algn="l">
-              <a:defRPr sz="1275" b="0">
-                <a:solidFill>
-                  <a:srgbClr val="1F2937"/>
-                </a:solidFill>
-              </a:defRPr>
-            </a:pPr>
-            <a:r>
-              <a:rPr sz="1275" b="0">
-                <a:solidFill>
-                  <a:srgbClr val="1F2937"/>
-                </a:solidFill>
-              </a:rPr>
-              <a:t>• Q2 reporting data book — v7 controller tie</a:t>
-            </a:r>
-          </a:p>
-          <a:p xmlns:a="http://schemas.openxmlformats.org/drawingml/2006/main">
-            <a:r>
-              <a:t/>
-            </a:r>
-          </a:p>
-          <a:p xmlns:a="http://schemas.openxmlformats.org/drawingml/2006/main">
-            <a:pPr algn="l">
-              <a:defRPr sz="1275" b="0">
-                <a:solidFill>
-                  <a:srgbClr val="1F2937"/>
-                </a:solidFill>
-              </a:defRPr>
-            </a:pPr>
-            <a:r>
-              <a:rPr sz="1275" b="0">
-                <a:solidFill>
-                  <a:srgbClr val="1F2937"/>
-                </a:solidFill>
-              </a:rPr>
-              <a:t>• Q2 reporting cube extract — 7.2 current</a:t>
-            </a:r>
-          </a:p>
-          <a:p xmlns:a="http://schemas.openxmlformats.org/drawingml/2006/main">
-            <a:r>
-              <a:t/>
-            </a:r>
-          </a:p>
-          <a:p xmlns:a="http://schemas.openxmlformats.org/drawingml/2006/main">
-            <a:pPr algn="l">
-              <a:defRPr sz="1275" b="0">
-                <a:solidFill>
-                  <a:srgbClr val="1F2937"/>
-                </a:solidFill>
-              </a:defRPr>
-            </a:pPr>
-            <a:r>
-              <a:rPr sz="1275" b="0">
-                <a:solidFill>
-                  <a:srgbClr val="1F2937"/>
-                </a:solidFill>
-              </a:rPr>
-              <a:t>• Board/lender review notes and KPI policy</a:t>
-            </a:r>
-          </a:p>
-          <a:p xmlns:a="http://schemas.openxmlformats.org/drawingml/2006/main">
-            <a:r>
-              <a:t/>
-            </a:r>
-          </a:p>
-          <a:p xmlns:a="http://schemas.openxmlformats.org/drawingml/2006/main">
-            <a:pPr algn="l">
-              <a:defRPr sz="1275" b="0">
-                <a:solidFill>
-                  <a:srgbClr val="1F2937"/>
-                </a:solidFill>
-              </a:defRPr>
-            </a:pPr>
-            <a:r>
-              <a:rPr sz="1275" b="0">
-                <a:solidFill>
-                  <a:srgbClr val="1F2937"/>
-                </a:solidFill>
-              </a:rPr>
-              <a:t>• Period: June and Q2 2026; FY26 latest outlook</a:t>
+            <a:r>
+              <a:t>—</a:t>
             </a:r>
           </a:p>
         </p:txBody>
@@ -19407,6 +18955,7 @@
           <a:lstStyle xmlns:a="http://schemas.openxmlformats.org/drawingml/2006/main"/>
           <a:p xmlns:a="http://schemas.openxmlformats.org/drawingml/2006/main">
             <a:pPr algn="l">
+              <a:buNone/>
               <a:defRPr sz="1275" b="1">
                 <a:solidFill>
                   <a:srgbClr val="17365D"/>
@@ -19419,7 +18968,7 @@
                   <a:srgbClr val="17365D"/>
                 </a:solidFill>
               </a:rPr>
-              <a:t>All headline figures must tie here before this deck is circulated.</a:t>
+              <a:t>—</a:t>
             </a:r>
           </a:p>
         </p:txBody>

</xml_diff>